<commit_message>
Trading cards redesigned (straight, photo on top, advice quote, 2x2 facts); hand-cut paper collage pack; real bios
</commit_message>
<xml_diff>
--- a/templates/posts/october/2026-10-06-tue-ig-mentor-carla-quote-card.pptx
+++ b/templates/posts/october/2026-10-06-tue-ig-mentor-carla-quote-card.pptx
@@ -3516,3379 +3516,9 @@
         <p:nvPr/>
       </p:nvGrpSpPr>
       <p:grpSpPr/>
-      <p:sp>
-        <p:nvSpPr>
-          <p:cNvPr id="2" name="Oval 1"/>
-          <p:cNvSpPr/>
-          <p:nvPr/>
-        </p:nvSpPr>
-        <p:spPr>
-          <a:xfrm>
-            <a:off x="190500" y="190500"/>
-            <a:ext cx="1143000" cy="1143000"/>
-          </a:xfrm>
-          <a:prstGeom prst="ellipse">
-            <a:avLst/>
-          </a:prstGeom>
-          <a:noFill/>
-          <a:ln w="19050">
-            <a:solidFill>
-              <a:srgbClr val="7F8F73"/>
-            </a:solidFill>
-          </a:ln>
-          <a:effectLst/>
-        </p:spPr>
-        <p:style>
-          <a:lnRef idx="1">
-            <a:schemeClr val="accent1"/>
-          </a:lnRef>
-          <a:fillRef idx="3">
-            <a:schemeClr val="accent1"/>
-          </a:fillRef>
-          <a:effectRef idx="2">
-            <a:schemeClr val="accent1"/>
-          </a:effectRef>
-          <a:fontRef idx="minor">
-            <a:schemeClr val="lt1"/>
-          </a:fontRef>
-        </p:style>
-        <p:txBody>
-          <a:bodyPr rtlCol="0" anchor="ctr"/>
-          <a:lstStyle/>
-          <a:p>
-            <a:pPr algn="ctr"/>
-          </a:p>
-        </p:txBody>
-      </p:sp>
-      <p:sp>
-        <p:nvSpPr>
-          <p:cNvPr id="3" name="Oval 2"/>
-          <p:cNvSpPr/>
-          <p:nvPr/>
-        </p:nvSpPr>
-        <p:spPr>
-          <a:xfrm>
-            <a:off x="1047750" y="733425"/>
-            <a:ext cx="57150" cy="57150"/>
-          </a:xfrm>
-          <a:prstGeom prst="ellipse">
-            <a:avLst/>
-          </a:prstGeom>
-          <a:solidFill>
-            <a:srgbClr val="7F8F73"/>
-          </a:solidFill>
-          <a:ln>
-            <a:noFill/>
-          </a:ln>
-          <a:effectLst/>
-        </p:spPr>
-        <p:style>
-          <a:lnRef idx="1">
-            <a:schemeClr val="accent1"/>
-          </a:lnRef>
-          <a:fillRef idx="3">
-            <a:schemeClr val="accent1"/>
-          </a:fillRef>
-          <a:effectRef idx="2">
-            <a:schemeClr val="accent1"/>
-          </a:effectRef>
-          <a:fontRef idx="minor">
-            <a:schemeClr val="lt1"/>
-          </a:fontRef>
-        </p:style>
-        <p:txBody>
-          <a:bodyPr rtlCol="0" anchor="ctr"/>
-          <a:lstStyle/>
-          <a:p>
-            <a:pPr algn="ctr"/>
-          </a:p>
-        </p:txBody>
-      </p:sp>
-      <p:sp>
-        <p:nvSpPr>
-          <p:cNvPr id="4" name="Oval 3"/>
-          <p:cNvSpPr/>
-          <p:nvPr/>
-        </p:nvSpPr>
-        <p:spPr>
-          <a:xfrm>
-            <a:off x="889824" y="1006077"/>
-            <a:ext cx="57150" cy="57150"/>
-          </a:xfrm>
-          <a:prstGeom prst="ellipse">
-            <a:avLst/>
-          </a:prstGeom>
-          <a:solidFill>
-            <a:srgbClr val="7F8F73"/>
-          </a:solidFill>
-          <a:ln>
-            <a:noFill/>
-          </a:ln>
-          <a:effectLst/>
-        </p:spPr>
-        <p:style>
-          <a:lnRef idx="1">
-            <a:schemeClr val="accent1"/>
-          </a:lnRef>
-          <a:fillRef idx="3">
-            <a:schemeClr val="accent1"/>
-          </a:fillRef>
-          <a:effectRef idx="2">
-            <a:schemeClr val="accent1"/>
-          </a:effectRef>
-          <a:fontRef idx="minor">
-            <a:schemeClr val="lt1"/>
-          </a:fontRef>
-        </p:style>
-        <p:txBody>
-          <a:bodyPr rtlCol="0" anchor="ctr"/>
-          <a:lstStyle/>
-          <a:p>
-            <a:pPr algn="ctr"/>
-          </a:p>
-        </p:txBody>
-      </p:sp>
-      <p:sp>
-        <p:nvSpPr>
-          <p:cNvPr id="5" name="Oval 4"/>
-          <p:cNvSpPr/>
-          <p:nvPr/>
-        </p:nvSpPr>
-        <p:spPr>
-          <a:xfrm>
-            <a:off x="574739" y="1004753"/>
-            <a:ext cx="57150" cy="57150"/>
-          </a:xfrm>
-          <a:prstGeom prst="ellipse">
-            <a:avLst/>
-          </a:prstGeom>
-          <a:solidFill>
-            <a:srgbClr val="7F8F73"/>
-          </a:solidFill>
-          <a:ln>
-            <a:noFill/>
-          </a:ln>
-          <a:effectLst/>
-        </p:spPr>
-        <p:style>
-          <a:lnRef idx="1">
-            <a:schemeClr val="accent1"/>
-          </a:lnRef>
-          <a:fillRef idx="3">
-            <a:schemeClr val="accent1"/>
-          </a:fillRef>
-          <a:effectRef idx="2">
-            <a:schemeClr val="accent1"/>
-          </a:effectRef>
-          <a:fontRef idx="minor">
-            <a:schemeClr val="lt1"/>
-          </a:fontRef>
-        </p:style>
-        <p:txBody>
-          <a:bodyPr rtlCol="0" anchor="ctr"/>
-          <a:lstStyle/>
-          <a:p>
-            <a:pPr algn="ctr"/>
-          </a:p>
-        </p:txBody>
-      </p:sp>
-      <p:sp>
-        <p:nvSpPr>
-          <p:cNvPr id="6" name="Oval 5"/>
-          <p:cNvSpPr/>
-          <p:nvPr/>
-        </p:nvSpPr>
-        <p:spPr>
-          <a:xfrm>
-            <a:off x="419111" y="730782"/>
-            <a:ext cx="57150" cy="57150"/>
-          </a:xfrm>
-          <a:prstGeom prst="ellipse">
-            <a:avLst/>
-          </a:prstGeom>
-          <a:solidFill>
-            <a:srgbClr val="7F8F73"/>
-          </a:solidFill>
-          <a:ln>
-            <a:noFill/>
-          </a:ln>
-          <a:effectLst/>
-        </p:spPr>
-        <p:style>
-          <a:lnRef idx="1">
-            <a:schemeClr val="accent1"/>
-          </a:lnRef>
-          <a:fillRef idx="3">
-            <a:schemeClr val="accent1"/>
-          </a:fillRef>
-          <a:effectRef idx="2">
-            <a:schemeClr val="accent1"/>
-          </a:effectRef>
-          <a:fontRef idx="minor">
-            <a:schemeClr val="lt1"/>
-          </a:fontRef>
-        </p:style>
-        <p:txBody>
-          <a:bodyPr rtlCol="0" anchor="ctr"/>
-          <a:lstStyle/>
-          <a:p>
-            <a:pPr algn="ctr"/>
-          </a:p>
-        </p:txBody>
-      </p:sp>
-      <p:sp>
-        <p:nvSpPr>
-          <p:cNvPr id="7" name="Oval 6"/>
-          <p:cNvSpPr/>
-          <p:nvPr/>
-        </p:nvSpPr>
-        <p:spPr>
-          <a:xfrm>
-            <a:off x="579323" y="459466"/>
-            <a:ext cx="57150" cy="57150"/>
-          </a:xfrm>
-          <a:prstGeom prst="ellipse">
-            <a:avLst/>
-          </a:prstGeom>
-          <a:solidFill>
-            <a:srgbClr val="7F8F73"/>
-          </a:solidFill>
-          <a:ln>
-            <a:noFill/>
-          </a:ln>
-          <a:effectLst/>
-        </p:spPr>
-        <p:style>
-          <a:lnRef idx="1">
-            <a:schemeClr val="accent1"/>
-          </a:lnRef>
-          <a:fillRef idx="3">
-            <a:schemeClr val="accent1"/>
-          </a:fillRef>
-          <a:effectRef idx="2">
-            <a:schemeClr val="accent1"/>
-          </a:effectRef>
-          <a:fontRef idx="minor">
-            <a:schemeClr val="lt1"/>
-          </a:fontRef>
-        </p:style>
-        <p:txBody>
-          <a:bodyPr rtlCol="0" anchor="ctr"/>
-          <a:lstStyle/>
-          <a:p>
-            <a:pPr algn="ctr"/>
-          </a:p>
-        </p:txBody>
-      </p:sp>
-      <p:sp>
-        <p:nvSpPr>
-          <p:cNvPr id="8" name="Oval 7"/>
-          <p:cNvSpPr/>
-          <p:nvPr/>
-        </p:nvSpPr>
-        <p:spPr>
-          <a:xfrm>
-            <a:off x="894386" y="463440"/>
-            <a:ext cx="57150" cy="57150"/>
-          </a:xfrm>
-          <a:prstGeom prst="ellipse">
-            <a:avLst/>
-          </a:prstGeom>
-          <a:solidFill>
-            <a:srgbClr val="7F8F73"/>
-          </a:solidFill>
-          <a:ln>
-            <a:noFill/>
-          </a:ln>
-          <a:effectLst/>
-        </p:spPr>
-        <p:style>
-          <a:lnRef idx="1">
-            <a:schemeClr val="accent1"/>
-          </a:lnRef>
-          <a:fillRef idx="3">
-            <a:schemeClr val="accent1"/>
-          </a:fillRef>
-          <a:effectRef idx="2">
-            <a:schemeClr val="accent1"/>
-          </a:effectRef>
-          <a:fontRef idx="minor">
-            <a:schemeClr val="lt1"/>
-          </a:fontRef>
-        </p:style>
-        <p:txBody>
-          <a:bodyPr rtlCol="0" anchor="ctr"/>
-          <a:lstStyle/>
-          <a:p>
-            <a:pPr algn="ctr"/>
-          </a:p>
-        </p:txBody>
-      </p:sp>
-      <p:sp>
-        <p:nvSpPr>
-          <p:cNvPr id="9" name="Oval 8"/>
-          <p:cNvSpPr/>
-          <p:nvPr/>
-        </p:nvSpPr>
-        <p:spPr>
-          <a:xfrm>
-            <a:off x="1143000" y="0"/>
-            <a:ext cx="952500" cy="952500"/>
-          </a:xfrm>
-          <a:prstGeom prst="ellipse">
-            <a:avLst/>
-          </a:prstGeom>
-          <a:noFill/>
-          <a:ln w="19050">
-            <a:solidFill>
-              <a:srgbClr val="7F8F73"/>
-            </a:solidFill>
-          </a:ln>
-          <a:effectLst/>
-        </p:spPr>
-        <p:style>
-          <a:lnRef idx="1">
-            <a:schemeClr val="accent1"/>
-          </a:lnRef>
-          <a:fillRef idx="3">
-            <a:schemeClr val="accent1"/>
-          </a:fillRef>
-          <a:effectRef idx="2">
-            <a:schemeClr val="accent1"/>
-          </a:effectRef>
-          <a:fontRef idx="minor">
-            <a:schemeClr val="lt1"/>
-          </a:fontRef>
-        </p:style>
-        <p:txBody>
-          <a:bodyPr rtlCol="0" anchor="ctr"/>
-          <a:lstStyle/>
-          <a:p>
-            <a:pPr algn="ctr"/>
-          </a:p>
-        </p:txBody>
-      </p:sp>
-      <p:sp>
-        <p:nvSpPr>
-          <p:cNvPr id="10" name="Oval 9"/>
-          <p:cNvSpPr/>
-          <p:nvPr/>
-        </p:nvSpPr>
-        <p:spPr>
-          <a:xfrm>
-            <a:off x="1852612" y="447675"/>
-            <a:ext cx="57150" cy="57150"/>
-          </a:xfrm>
-          <a:prstGeom prst="ellipse">
-            <a:avLst/>
-          </a:prstGeom>
-          <a:solidFill>
-            <a:srgbClr val="7F8F73"/>
-          </a:solidFill>
-          <a:ln>
-            <a:noFill/>
-          </a:ln>
-          <a:effectLst/>
-        </p:spPr>
-        <p:style>
-          <a:lnRef idx="1">
-            <a:schemeClr val="accent1"/>
-          </a:lnRef>
-          <a:fillRef idx="3">
-            <a:schemeClr val="accent1"/>
-          </a:fillRef>
-          <a:effectRef idx="2">
-            <a:schemeClr val="accent1"/>
-          </a:effectRef>
-          <a:fontRef idx="minor">
-            <a:schemeClr val="lt1"/>
-          </a:fontRef>
-        </p:style>
-        <p:txBody>
-          <a:bodyPr rtlCol="0" anchor="ctr"/>
-          <a:lstStyle/>
-          <a:p>
-            <a:pPr algn="ctr"/>
-          </a:p>
-        </p:txBody>
-      </p:sp>
-      <p:sp>
-        <p:nvSpPr>
-          <p:cNvPr id="11" name="Oval 10"/>
-          <p:cNvSpPr/>
-          <p:nvPr/>
-        </p:nvSpPr>
-        <p:spPr>
-          <a:xfrm>
-            <a:off x="1721007" y="674885"/>
-            <a:ext cx="57150" cy="57150"/>
-          </a:xfrm>
-          <a:prstGeom prst="ellipse">
-            <a:avLst/>
-          </a:prstGeom>
-          <a:solidFill>
-            <a:srgbClr val="7F8F73"/>
-          </a:solidFill>
-          <a:ln>
-            <a:noFill/>
-          </a:ln>
-          <a:effectLst/>
-        </p:spPr>
-        <p:style>
-          <a:lnRef idx="1">
-            <a:schemeClr val="accent1"/>
-          </a:lnRef>
-          <a:fillRef idx="3">
-            <a:schemeClr val="accent1"/>
-          </a:fillRef>
-          <a:effectRef idx="2">
-            <a:schemeClr val="accent1"/>
-          </a:effectRef>
-          <a:fontRef idx="minor">
-            <a:schemeClr val="lt1"/>
-          </a:fontRef>
-        </p:style>
-        <p:txBody>
-          <a:bodyPr rtlCol="0" anchor="ctr"/>
-          <a:lstStyle/>
-          <a:p>
-            <a:pPr algn="ctr"/>
-          </a:p>
-        </p:txBody>
-      </p:sp>
-      <p:sp>
-        <p:nvSpPr>
-          <p:cNvPr id="12" name="Oval 11"/>
-          <p:cNvSpPr/>
-          <p:nvPr/>
-        </p:nvSpPr>
-        <p:spPr>
-          <a:xfrm>
-            <a:off x="1458436" y="673781"/>
-            <a:ext cx="57150" cy="57150"/>
-          </a:xfrm>
-          <a:prstGeom prst="ellipse">
-            <a:avLst/>
-          </a:prstGeom>
-          <a:solidFill>
-            <a:srgbClr val="7F8F73"/>
-          </a:solidFill>
-          <a:ln>
-            <a:noFill/>
-          </a:ln>
-          <a:effectLst/>
-        </p:spPr>
-        <p:style>
-          <a:lnRef idx="1">
-            <a:schemeClr val="accent1"/>
-          </a:lnRef>
-          <a:fillRef idx="3">
-            <a:schemeClr val="accent1"/>
-          </a:fillRef>
-          <a:effectRef idx="2">
-            <a:schemeClr val="accent1"/>
-          </a:effectRef>
-          <a:fontRef idx="minor">
-            <a:schemeClr val="lt1"/>
-          </a:fontRef>
-        </p:style>
-        <p:txBody>
-          <a:bodyPr rtlCol="0" anchor="ctr"/>
-          <a:lstStyle/>
-          <a:p>
-            <a:pPr algn="ctr"/>
-          </a:p>
-        </p:txBody>
-      </p:sp>
-      <p:sp>
-        <p:nvSpPr>
-          <p:cNvPr id="13" name="Oval 12"/>
-          <p:cNvSpPr/>
-          <p:nvPr/>
-        </p:nvSpPr>
-        <p:spPr>
-          <a:xfrm>
-            <a:off x="1328746" y="445472"/>
-            <a:ext cx="57150" cy="57150"/>
-          </a:xfrm>
-          <a:prstGeom prst="ellipse">
-            <a:avLst/>
-          </a:prstGeom>
-          <a:solidFill>
-            <a:srgbClr val="7F8F73"/>
-          </a:solidFill>
-          <a:ln>
-            <a:noFill/>
-          </a:ln>
-          <a:effectLst/>
-        </p:spPr>
-        <p:style>
-          <a:lnRef idx="1">
-            <a:schemeClr val="accent1"/>
-          </a:lnRef>
-          <a:fillRef idx="3">
-            <a:schemeClr val="accent1"/>
-          </a:fillRef>
-          <a:effectRef idx="2">
-            <a:schemeClr val="accent1"/>
-          </a:effectRef>
-          <a:fontRef idx="minor">
-            <a:schemeClr val="lt1"/>
-          </a:fontRef>
-        </p:style>
-        <p:txBody>
-          <a:bodyPr rtlCol="0" anchor="ctr"/>
-          <a:lstStyle/>
-          <a:p>
-            <a:pPr algn="ctr"/>
-          </a:p>
-        </p:txBody>
-      </p:sp>
-      <p:sp>
-        <p:nvSpPr>
-          <p:cNvPr id="14" name="Oval 13"/>
-          <p:cNvSpPr/>
-          <p:nvPr/>
-        </p:nvSpPr>
-        <p:spPr>
-          <a:xfrm>
-            <a:off x="1462257" y="219376"/>
-            <a:ext cx="57150" cy="57150"/>
-          </a:xfrm>
-          <a:prstGeom prst="ellipse">
-            <a:avLst/>
-          </a:prstGeom>
-          <a:solidFill>
-            <a:srgbClr val="7F8F73"/>
-          </a:solidFill>
-          <a:ln>
-            <a:noFill/>
-          </a:ln>
-          <a:effectLst/>
-        </p:spPr>
-        <p:style>
-          <a:lnRef idx="1">
-            <a:schemeClr val="accent1"/>
-          </a:lnRef>
-          <a:fillRef idx="3">
-            <a:schemeClr val="accent1"/>
-          </a:fillRef>
-          <a:effectRef idx="2">
-            <a:schemeClr val="accent1"/>
-          </a:effectRef>
-          <a:fontRef idx="minor">
-            <a:schemeClr val="lt1"/>
-          </a:fontRef>
-        </p:style>
-        <p:txBody>
-          <a:bodyPr rtlCol="0" anchor="ctr"/>
-          <a:lstStyle/>
-          <a:p>
-            <a:pPr algn="ctr"/>
-          </a:p>
-        </p:txBody>
-      </p:sp>
-      <p:sp>
-        <p:nvSpPr>
-          <p:cNvPr id="15" name="Oval 14"/>
-          <p:cNvSpPr/>
-          <p:nvPr/>
-        </p:nvSpPr>
-        <p:spPr>
-          <a:xfrm>
-            <a:off x="1724809" y="222687"/>
-            <a:ext cx="57150" cy="57150"/>
-          </a:xfrm>
-          <a:prstGeom prst="ellipse">
-            <a:avLst/>
-          </a:prstGeom>
-          <a:solidFill>
-            <a:srgbClr val="7F8F73"/>
-          </a:solidFill>
-          <a:ln>
-            <a:noFill/>
-          </a:ln>
-          <a:effectLst/>
-        </p:spPr>
-        <p:style>
-          <a:lnRef idx="1">
-            <a:schemeClr val="accent1"/>
-          </a:lnRef>
-          <a:fillRef idx="3">
-            <a:schemeClr val="accent1"/>
-          </a:fillRef>
-          <a:effectRef idx="2">
-            <a:schemeClr val="accent1"/>
-          </a:effectRef>
-          <a:fontRef idx="minor">
-            <a:schemeClr val="lt1"/>
-          </a:fontRef>
-        </p:style>
-        <p:txBody>
-          <a:bodyPr rtlCol="0" anchor="ctr"/>
-          <a:lstStyle/>
-          <a:p>
-            <a:pPr algn="ctr"/>
-          </a:p>
-        </p:txBody>
-      </p:sp>
-      <p:sp>
-        <p:nvSpPr>
-          <p:cNvPr id="16" name="Oval 15"/>
-          <p:cNvSpPr/>
-          <p:nvPr/>
-        </p:nvSpPr>
-        <p:spPr>
-          <a:xfrm>
-            <a:off x="133350" y="1371600"/>
-            <a:ext cx="876300" cy="876300"/>
-          </a:xfrm>
-          <a:prstGeom prst="ellipse">
-            <a:avLst/>
-          </a:prstGeom>
-          <a:noFill/>
-          <a:ln w="19050">
-            <a:solidFill>
-              <a:srgbClr val="7F8F73"/>
-            </a:solidFill>
-          </a:ln>
-          <a:effectLst/>
-        </p:spPr>
-        <p:style>
-          <a:lnRef idx="1">
-            <a:schemeClr val="accent1"/>
-          </a:lnRef>
-          <a:fillRef idx="3">
-            <a:schemeClr val="accent1"/>
-          </a:fillRef>
-          <a:effectRef idx="2">
-            <a:schemeClr val="accent1"/>
-          </a:effectRef>
-          <a:fontRef idx="minor">
-            <a:schemeClr val="lt1"/>
-          </a:fontRef>
-        </p:style>
-        <p:txBody>
-          <a:bodyPr rtlCol="0" anchor="ctr"/>
-          <a:lstStyle/>
-          <a:p>
-            <a:pPr algn="ctr"/>
-          </a:p>
-        </p:txBody>
-      </p:sp>
-      <p:sp>
-        <p:nvSpPr>
-          <p:cNvPr id="17" name="Oval 16"/>
-          <p:cNvSpPr/>
-          <p:nvPr/>
-        </p:nvSpPr>
-        <p:spPr>
-          <a:xfrm>
-            <a:off x="783907" y="1781175"/>
-            <a:ext cx="57150" cy="57150"/>
-          </a:xfrm>
-          <a:prstGeom prst="ellipse">
-            <a:avLst/>
-          </a:prstGeom>
-          <a:solidFill>
-            <a:srgbClr val="7F8F73"/>
-          </a:solidFill>
-          <a:ln>
-            <a:noFill/>
-          </a:ln>
-          <a:effectLst/>
-        </p:spPr>
-        <p:style>
-          <a:lnRef idx="1">
-            <a:schemeClr val="accent1"/>
-          </a:lnRef>
-          <a:fillRef idx="3">
-            <a:schemeClr val="accent1"/>
-          </a:fillRef>
-          <a:effectRef idx="2">
-            <a:schemeClr val="accent1"/>
-          </a:effectRef>
-          <a:fontRef idx="minor">
-            <a:schemeClr val="lt1"/>
-          </a:fontRef>
-        </p:style>
-        <p:txBody>
-          <a:bodyPr rtlCol="0" anchor="ctr"/>
-          <a:lstStyle/>
-          <a:p>
-            <a:pPr algn="ctr"/>
-          </a:p>
-        </p:txBody>
-      </p:sp>
-      <p:sp>
-        <p:nvSpPr>
-          <p:cNvPr id="18" name="Oval 17"/>
-          <p:cNvSpPr/>
-          <p:nvPr/>
-        </p:nvSpPr>
-        <p:spPr>
-          <a:xfrm>
-            <a:off x="662830" y="1990208"/>
-            <a:ext cx="57150" cy="57150"/>
-          </a:xfrm>
-          <a:prstGeom prst="ellipse">
-            <a:avLst/>
-          </a:prstGeom>
-          <a:solidFill>
-            <a:srgbClr val="7F8F73"/>
-          </a:solidFill>
-          <a:ln>
-            <a:noFill/>
-          </a:ln>
-          <a:effectLst/>
-        </p:spPr>
-        <p:style>
-          <a:lnRef idx="1">
-            <a:schemeClr val="accent1"/>
-          </a:lnRef>
-          <a:fillRef idx="3">
-            <a:schemeClr val="accent1"/>
-          </a:fillRef>
-          <a:effectRef idx="2">
-            <a:schemeClr val="accent1"/>
-          </a:effectRef>
-          <a:fontRef idx="minor">
-            <a:schemeClr val="lt1"/>
-          </a:fontRef>
-        </p:style>
-        <p:txBody>
-          <a:bodyPr rtlCol="0" anchor="ctr"/>
-          <a:lstStyle/>
-          <a:p>
-            <a:pPr algn="ctr"/>
-          </a:p>
-        </p:txBody>
-      </p:sp>
-      <p:sp>
-        <p:nvSpPr>
-          <p:cNvPr id="19" name="Oval 18"/>
-          <p:cNvSpPr/>
-          <p:nvPr/>
-        </p:nvSpPr>
-        <p:spPr>
-          <a:xfrm>
-            <a:off x="421265" y="1989193"/>
-            <a:ext cx="57150" cy="57150"/>
-          </a:xfrm>
-          <a:prstGeom prst="ellipse">
-            <a:avLst/>
-          </a:prstGeom>
-          <a:solidFill>
-            <a:srgbClr val="7F8F73"/>
-          </a:solidFill>
-          <a:ln>
-            <a:noFill/>
-          </a:ln>
-          <a:effectLst/>
-        </p:spPr>
-        <p:style>
-          <a:lnRef idx="1">
-            <a:schemeClr val="accent1"/>
-          </a:lnRef>
-          <a:fillRef idx="3">
-            <a:schemeClr val="accent1"/>
-          </a:fillRef>
-          <a:effectRef idx="2">
-            <a:schemeClr val="accent1"/>
-          </a:effectRef>
-          <a:fontRef idx="minor">
-            <a:schemeClr val="lt1"/>
-          </a:fontRef>
-        </p:style>
-        <p:txBody>
-          <a:bodyPr rtlCol="0" anchor="ctr"/>
-          <a:lstStyle/>
-          <a:p>
-            <a:pPr algn="ctr"/>
-          </a:p>
-        </p:txBody>
-      </p:sp>
-      <p:sp>
-        <p:nvSpPr>
-          <p:cNvPr id="20" name="Oval 19"/>
-          <p:cNvSpPr/>
-          <p:nvPr/>
-        </p:nvSpPr>
-        <p:spPr>
-          <a:xfrm>
-            <a:off x="301951" y="1779149"/>
-            <a:ext cx="57150" cy="57150"/>
-          </a:xfrm>
-          <a:prstGeom prst="ellipse">
-            <a:avLst/>
-          </a:prstGeom>
-          <a:solidFill>
-            <a:srgbClr val="7F8F73"/>
-          </a:solidFill>
-          <a:ln>
-            <a:noFill/>
-          </a:ln>
-          <a:effectLst/>
-        </p:spPr>
-        <p:style>
-          <a:lnRef idx="1">
-            <a:schemeClr val="accent1"/>
-          </a:lnRef>
-          <a:fillRef idx="3">
-            <a:schemeClr val="accent1"/>
-          </a:fillRef>
-          <a:effectRef idx="2">
-            <a:schemeClr val="accent1"/>
-          </a:effectRef>
-          <a:fontRef idx="minor">
-            <a:schemeClr val="lt1"/>
-          </a:fontRef>
-        </p:style>
-        <p:txBody>
-          <a:bodyPr rtlCol="0" anchor="ctr"/>
-          <a:lstStyle/>
-          <a:p>
-            <a:pPr algn="ctr"/>
-          </a:p>
-        </p:txBody>
-      </p:sp>
-      <p:sp>
-        <p:nvSpPr>
-          <p:cNvPr id="21" name="Oval 20"/>
-          <p:cNvSpPr/>
-          <p:nvPr/>
-        </p:nvSpPr>
-        <p:spPr>
-          <a:xfrm>
-            <a:off x="424780" y="1571140"/>
-            <a:ext cx="57150" cy="57150"/>
-          </a:xfrm>
-          <a:prstGeom prst="ellipse">
-            <a:avLst/>
-          </a:prstGeom>
-          <a:solidFill>
-            <a:srgbClr val="7F8F73"/>
-          </a:solidFill>
-          <a:ln>
-            <a:noFill/>
-          </a:ln>
-          <a:effectLst/>
-        </p:spPr>
-        <p:style>
-          <a:lnRef idx="1">
-            <a:schemeClr val="accent1"/>
-          </a:lnRef>
-          <a:fillRef idx="3">
-            <a:schemeClr val="accent1"/>
-          </a:fillRef>
-          <a:effectRef idx="2">
-            <a:schemeClr val="accent1"/>
-          </a:effectRef>
-          <a:fontRef idx="minor">
-            <a:schemeClr val="lt1"/>
-          </a:fontRef>
-        </p:style>
-        <p:txBody>
-          <a:bodyPr rtlCol="0" anchor="ctr"/>
-          <a:lstStyle/>
-          <a:p>
-            <a:pPr algn="ctr"/>
-          </a:p>
-        </p:txBody>
-      </p:sp>
-      <p:sp>
-        <p:nvSpPr>
-          <p:cNvPr id="22" name="Oval 21"/>
-          <p:cNvSpPr/>
-          <p:nvPr/>
-        </p:nvSpPr>
-        <p:spPr>
-          <a:xfrm>
-            <a:off x="666328" y="1574186"/>
-            <a:ext cx="57150" cy="57150"/>
-          </a:xfrm>
-          <a:prstGeom prst="ellipse">
-            <a:avLst/>
-          </a:prstGeom>
-          <a:solidFill>
-            <a:srgbClr val="7F8F73"/>
-          </a:solidFill>
-          <a:ln>
-            <a:noFill/>
-          </a:ln>
-          <a:effectLst/>
-        </p:spPr>
-        <p:style>
-          <a:lnRef idx="1">
-            <a:schemeClr val="accent1"/>
-          </a:lnRef>
-          <a:fillRef idx="3">
-            <a:schemeClr val="accent1"/>
-          </a:fillRef>
-          <a:effectRef idx="2">
-            <a:schemeClr val="accent1"/>
-          </a:effectRef>
-          <a:fontRef idx="minor">
-            <a:schemeClr val="lt1"/>
-          </a:fontRef>
-        </p:style>
-        <p:txBody>
-          <a:bodyPr rtlCol="0" anchor="ctr"/>
-          <a:lstStyle/>
-          <a:p>
-            <a:pPr algn="ctr"/>
-          </a:p>
-        </p:txBody>
-      </p:sp>
-      <p:sp>
-        <p:nvSpPr>
-          <p:cNvPr id="23" name="Oval 22"/>
-          <p:cNvSpPr/>
-          <p:nvPr/>
-        </p:nvSpPr>
-        <p:spPr>
-          <a:xfrm>
-            <a:off x="1962150" y="723900"/>
-            <a:ext cx="838200" cy="838200"/>
-          </a:xfrm>
-          <a:prstGeom prst="ellipse">
-            <a:avLst/>
-          </a:prstGeom>
-          <a:noFill/>
-          <a:ln w="19050">
-            <a:solidFill>
-              <a:srgbClr val="7F8F73"/>
-            </a:solidFill>
-          </a:ln>
-          <a:effectLst/>
-        </p:spPr>
-        <p:style>
-          <a:lnRef idx="1">
-            <a:schemeClr val="accent1"/>
-          </a:lnRef>
-          <a:fillRef idx="3">
-            <a:schemeClr val="accent1"/>
-          </a:fillRef>
-          <a:effectRef idx="2">
-            <a:schemeClr val="accent1"/>
-          </a:effectRef>
-          <a:fontRef idx="minor">
-            <a:schemeClr val="lt1"/>
-          </a:fontRef>
-        </p:style>
-        <p:txBody>
-          <a:bodyPr rtlCol="0" anchor="ctr"/>
-          <a:lstStyle/>
-          <a:p>
-            <a:pPr algn="ctr"/>
-          </a:p>
-        </p:txBody>
-      </p:sp>
-      <p:sp>
-        <p:nvSpPr>
-          <p:cNvPr id="24" name="Oval 23"/>
-          <p:cNvSpPr/>
-          <p:nvPr/>
-        </p:nvSpPr>
-        <p:spPr>
-          <a:xfrm>
-            <a:off x="2583180" y="1114425"/>
-            <a:ext cx="57150" cy="57150"/>
-          </a:xfrm>
-          <a:prstGeom prst="ellipse">
-            <a:avLst/>
-          </a:prstGeom>
-          <a:solidFill>
-            <a:srgbClr val="7F8F73"/>
-          </a:solidFill>
-          <a:ln>
-            <a:noFill/>
-          </a:ln>
-          <a:effectLst/>
-        </p:spPr>
-        <p:style>
-          <a:lnRef idx="1">
-            <a:schemeClr val="accent1"/>
-          </a:lnRef>
-          <a:fillRef idx="3">
-            <a:schemeClr val="accent1"/>
-          </a:fillRef>
-          <a:effectRef idx="2">
-            <a:schemeClr val="accent1"/>
-          </a:effectRef>
-          <a:fontRef idx="minor">
-            <a:schemeClr val="lt1"/>
-          </a:fontRef>
-        </p:style>
-        <p:txBody>
-          <a:bodyPr rtlCol="0" anchor="ctr"/>
-          <a:lstStyle/>
-          <a:p>
-            <a:pPr algn="ctr"/>
-          </a:p>
-        </p:txBody>
-      </p:sp>
-      <p:sp>
-        <p:nvSpPr>
-          <p:cNvPr id="25" name="Oval 24"/>
-          <p:cNvSpPr/>
-          <p:nvPr/>
-        </p:nvSpPr>
-        <p:spPr>
-          <a:xfrm>
-            <a:off x="2467367" y="1314370"/>
-            <a:ext cx="57150" cy="57150"/>
-          </a:xfrm>
-          <a:prstGeom prst="ellipse">
-            <a:avLst/>
-          </a:prstGeom>
-          <a:solidFill>
-            <a:srgbClr val="7F8F73"/>
-          </a:solidFill>
-          <a:ln>
-            <a:noFill/>
-          </a:ln>
-          <a:effectLst/>
-        </p:spPr>
-        <p:style>
-          <a:lnRef idx="1">
-            <a:schemeClr val="accent1"/>
-          </a:lnRef>
-          <a:fillRef idx="3">
-            <a:schemeClr val="accent1"/>
-          </a:fillRef>
-          <a:effectRef idx="2">
-            <a:schemeClr val="accent1"/>
-          </a:effectRef>
-          <a:fontRef idx="minor">
-            <a:schemeClr val="lt1"/>
-          </a:fontRef>
-        </p:style>
-        <p:txBody>
-          <a:bodyPr rtlCol="0" anchor="ctr"/>
-          <a:lstStyle/>
-          <a:p>
-            <a:pPr algn="ctr"/>
-          </a:p>
-        </p:txBody>
-      </p:sp>
-      <p:sp>
-        <p:nvSpPr>
-          <p:cNvPr id="26" name="Oval 25"/>
-          <p:cNvSpPr/>
-          <p:nvPr/>
-        </p:nvSpPr>
-        <p:spPr>
-          <a:xfrm>
-            <a:off x="2236305" y="1313399"/>
-            <a:ext cx="57150" cy="57150"/>
-          </a:xfrm>
-          <a:prstGeom prst="ellipse">
-            <a:avLst/>
-          </a:prstGeom>
-          <a:solidFill>
-            <a:srgbClr val="7F8F73"/>
-          </a:solidFill>
-          <a:ln>
-            <a:noFill/>
-          </a:ln>
-          <a:effectLst/>
-        </p:spPr>
-        <p:style>
-          <a:lnRef idx="1">
-            <a:schemeClr val="accent1"/>
-          </a:lnRef>
-          <a:fillRef idx="3">
-            <a:schemeClr val="accent1"/>
-          </a:fillRef>
-          <a:effectRef idx="2">
-            <a:schemeClr val="accent1"/>
-          </a:effectRef>
-          <a:fontRef idx="minor">
-            <a:schemeClr val="lt1"/>
-          </a:fontRef>
-        </p:style>
-        <p:txBody>
-          <a:bodyPr rtlCol="0" anchor="ctr"/>
-          <a:lstStyle/>
-          <a:p>
-            <a:pPr algn="ctr"/>
-          </a:p>
-        </p:txBody>
-      </p:sp>
-      <p:sp>
-        <p:nvSpPr>
-          <p:cNvPr id="27" name="Oval 26"/>
-          <p:cNvSpPr/>
-          <p:nvPr/>
-        </p:nvSpPr>
-        <p:spPr>
-          <a:xfrm>
-            <a:off x="2122178" y="1112487"/>
-            <a:ext cx="57150" cy="57150"/>
-          </a:xfrm>
-          <a:prstGeom prst="ellipse">
-            <a:avLst/>
-          </a:prstGeom>
-          <a:solidFill>
-            <a:srgbClr val="7F8F73"/>
-          </a:solidFill>
-          <a:ln>
-            <a:noFill/>
-          </a:ln>
-          <a:effectLst/>
-        </p:spPr>
-        <p:style>
-          <a:lnRef idx="1">
-            <a:schemeClr val="accent1"/>
-          </a:lnRef>
-          <a:fillRef idx="3">
-            <a:schemeClr val="accent1"/>
-          </a:fillRef>
-          <a:effectRef idx="2">
-            <a:schemeClr val="accent1"/>
-          </a:effectRef>
-          <a:fontRef idx="minor">
-            <a:schemeClr val="lt1"/>
-          </a:fontRef>
-        </p:style>
-        <p:txBody>
-          <a:bodyPr rtlCol="0" anchor="ctr"/>
-          <a:lstStyle/>
-          <a:p>
-            <a:pPr algn="ctr"/>
-          </a:p>
-        </p:txBody>
-      </p:sp>
-      <p:sp>
-        <p:nvSpPr>
-          <p:cNvPr id="28" name="Oval 27"/>
-          <p:cNvSpPr/>
-          <p:nvPr/>
-        </p:nvSpPr>
-        <p:spPr>
-          <a:xfrm>
-            <a:off x="2239667" y="913522"/>
-            <a:ext cx="57150" cy="57150"/>
-          </a:xfrm>
-          <a:prstGeom prst="ellipse">
-            <a:avLst/>
-          </a:prstGeom>
-          <a:solidFill>
-            <a:srgbClr val="7F8F73"/>
-          </a:solidFill>
-          <a:ln>
-            <a:noFill/>
-          </a:ln>
-          <a:effectLst/>
-        </p:spPr>
-        <p:style>
-          <a:lnRef idx="1">
-            <a:schemeClr val="accent1"/>
-          </a:lnRef>
-          <a:fillRef idx="3">
-            <a:schemeClr val="accent1"/>
-          </a:fillRef>
-          <a:effectRef idx="2">
-            <a:schemeClr val="accent1"/>
-          </a:effectRef>
-          <a:fontRef idx="minor">
-            <a:schemeClr val="lt1"/>
-          </a:fontRef>
-        </p:style>
-        <p:txBody>
-          <a:bodyPr rtlCol="0" anchor="ctr"/>
-          <a:lstStyle/>
-          <a:p>
-            <a:pPr algn="ctr"/>
-          </a:p>
-        </p:txBody>
-      </p:sp>
-      <p:sp>
-        <p:nvSpPr>
-          <p:cNvPr id="29" name="Oval 28"/>
-          <p:cNvSpPr/>
-          <p:nvPr/>
-        </p:nvSpPr>
-        <p:spPr>
-          <a:xfrm>
-            <a:off x="2470713" y="916436"/>
-            <a:ext cx="57150" cy="57150"/>
-          </a:xfrm>
-          <a:prstGeom prst="ellipse">
-            <a:avLst/>
-          </a:prstGeom>
-          <a:solidFill>
-            <a:srgbClr val="7F8F73"/>
-          </a:solidFill>
-          <a:ln>
-            <a:noFill/>
-          </a:ln>
-          <a:effectLst/>
-        </p:spPr>
-        <p:style>
-          <a:lnRef idx="1">
-            <a:schemeClr val="accent1"/>
-          </a:lnRef>
-          <a:fillRef idx="3">
-            <a:schemeClr val="accent1"/>
-          </a:fillRef>
-          <a:effectRef idx="2">
-            <a:schemeClr val="accent1"/>
-          </a:effectRef>
-          <a:fontRef idx="minor">
-            <a:schemeClr val="lt1"/>
-          </a:fontRef>
-        </p:style>
-        <p:txBody>
-          <a:bodyPr rtlCol="0" anchor="ctr"/>
-          <a:lstStyle/>
-          <a:p>
-            <a:pPr algn="ctr"/>
-          </a:p>
-        </p:txBody>
-      </p:sp>
-      <p:sp>
-        <p:nvSpPr>
-          <p:cNvPr id="30" name="Oval 29"/>
-          <p:cNvSpPr/>
-          <p:nvPr/>
-        </p:nvSpPr>
-        <p:spPr>
-          <a:xfrm>
-            <a:off x="857250" y="1047750"/>
-            <a:ext cx="762000" cy="762000"/>
-          </a:xfrm>
-          <a:prstGeom prst="ellipse">
-            <a:avLst/>
-          </a:prstGeom>
-          <a:noFill/>
-          <a:ln w="19050">
-            <a:solidFill>
-              <a:srgbClr val="7F8F73"/>
-            </a:solidFill>
-          </a:ln>
-          <a:effectLst/>
-        </p:spPr>
-        <p:style>
-          <a:lnRef idx="1">
-            <a:schemeClr val="accent1"/>
-          </a:lnRef>
-          <a:fillRef idx="3">
-            <a:schemeClr val="accent1"/>
-          </a:fillRef>
-          <a:effectRef idx="2">
-            <a:schemeClr val="accent1"/>
-          </a:effectRef>
-          <a:fontRef idx="minor">
-            <a:schemeClr val="lt1"/>
-          </a:fontRef>
-        </p:style>
-        <p:txBody>
-          <a:bodyPr rtlCol="0" anchor="ctr"/>
-          <a:lstStyle/>
-          <a:p>
-            <a:pPr algn="ctr"/>
-          </a:p>
-        </p:txBody>
-      </p:sp>
-      <p:sp>
-        <p:nvSpPr>
-          <p:cNvPr id="31" name="Oval 30"/>
-          <p:cNvSpPr/>
-          <p:nvPr/>
-        </p:nvSpPr>
-        <p:spPr>
-          <a:xfrm>
-            <a:off x="1419225" y="1400175"/>
-            <a:ext cx="57150" cy="57150"/>
-          </a:xfrm>
-          <a:prstGeom prst="ellipse">
-            <a:avLst/>
-          </a:prstGeom>
-          <a:solidFill>
-            <a:srgbClr val="7F8F73"/>
-          </a:solidFill>
-          <a:ln>
-            <a:noFill/>
-          </a:ln>
-          <a:effectLst/>
-        </p:spPr>
-        <p:style>
-          <a:lnRef idx="1">
-            <a:schemeClr val="accent1"/>
-          </a:lnRef>
-          <a:fillRef idx="3">
-            <a:schemeClr val="accent1"/>
-          </a:fillRef>
-          <a:effectRef idx="2">
-            <a:schemeClr val="accent1"/>
-          </a:effectRef>
-          <a:fontRef idx="minor">
-            <a:schemeClr val="lt1"/>
-          </a:fontRef>
-        </p:style>
-        <p:txBody>
-          <a:bodyPr rtlCol="0" anchor="ctr"/>
-          <a:lstStyle/>
-          <a:p>
-            <a:pPr algn="ctr"/>
-          </a:p>
-        </p:txBody>
-      </p:sp>
-      <p:sp>
-        <p:nvSpPr>
-          <p:cNvPr id="32" name="Oval 31"/>
-          <p:cNvSpPr/>
-          <p:nvPr/>
-        </p:nvSpPr>
-        <p:spPr>
-          <a:xfrm>
-            <a:off x="1313941" y="1581943"/>
-            <a:ext cx="57150" cy="57150"/>
-          </a:xfrm>
-          <a:prstGeom prst="ellipse">
-            <a:avLst/>
-          </a:prstGeom>
-          <a:solidFill>
-            <a:srgbClr val="7F8F73"/>
-          </a:solidFill>
-          <a:ln>
-            <a:noFill/>
-          </a:ln>
-          <a:effectLst/>
-        </p:spPr>
-        <p:style>
-          <a:lnRef idx="1">
-            <a:schemeClr val="accent1"/>
-          </a:lnRef>
-          <a:fillRef idx="3">
-            <a:schemeClr val="accent1"/>
-          </a:fillRef>
-          <a:effectRef idx="2">
-            <a:schemeClr val="accent1"/>
-          </a:effectRef>
-          <a:fontRef idx="minor">
-            <a:schemeClr val="lt1"/>
-          </a:fontRef>
-        </p:style>
-        <p:txBody>
-          <a:bodyPr rtlCol="0" anchor="ctr"/>
-          <a:lstStyle/>
-          <a:p>
-            <a:pPr algn="ctr"/>
-          </a:p>
-        </p:txBody>
-      </p:sp>
-      <p:sp>
-        <p:nvSpPr>
-          <p:cNvPr id="33" name="Oval 32"/>
-          <p:cNvSpPr/>
-          <p:nvPr/>
-        </p:nvSpPr>
-        <p:spPr>
-          <a:xfrm>
-            <a:off x="1103884" y="1581060"/>
-            <a:ext cx="57150" cy="57150"/>
-          </a:xfrm>
-          <a:prstGeom prst="ellipse">
-            <a:avLst/>
-          </a:prstGeom>
-          <a:solidFill>
-            <a:srgbClr val="7F8F73"/>
-          </a:solidFill>
-          <a:ln>
-            <a:noFill/>
-          </a:ln>
-          <a:effectLst/>
-        </p:spPr>
-        <p:style>
-          <a:lnRef idx="1">
-            <a:schemeClr val="accent1"/>
-          </a:lnRef>
-          <a:fillRef idx="3">
-            <a:schemeClr val="accent1"/>
-          </a:fillRef>
-          <a:effectRef idx="2">
-            <a:schemeClr val="accent1"/>
-          </a:effectRef>
-          <a:fontRef idx="minor">
-            <a:schemeClr val="lt1"/>
-          </a:fontRef>
-        </p:style>
-        <p:txBody>
-          <a:bodyPr rtlCol="0" anchor="ctr"/>
-          <a:lstStyle/>
-          <a:p>
-            <a:pPr algn="ctr"/>
-          </a:p>
-        </p:txBody>
-      </p:sp>
-      <p:sp>
-        <p:nvSpPr>
-          <p:cNvPr id="34" name="Oval 33"/>
-          <p:cNvSpPr/>
-          <p:nvPr/>
-        </p:nvSpPr>
-        <p:spPr>
-          <a:xfrm>
-            <a:off x="1000132" y="1398413"/>
-            <a:ext cx="57150" cy="57150"/>
-          </a:xfrm>
-          <a:prstGeom prst="ellipse">
-            <a:avLst/>
-          </a:prstGeom>
-          <a:solidFill>
-            <a:srgbClr val="7F8F73"/>
-          </a:solidFill>
-          <a:ln>
-            <a:noFill/>
-          </a:ln>
-          <a:effectLst/>
-        </p:spPr>
-        <p:style>
-          <a:lnRef idx="1">
-            <a:schemeClr val="accent1"/>
-          </a:lnRef>
-          <a:fillRef idx="3">
-            <a:schemeClr val="accent1"/>
-          </a:fillRef>
-          <a:effectRef idx="2">
-            <a:schemeClr val="accent1"/>
-          </a:effectRef>
-          <a:fontRef idx="minor">
-            <a:schemeClr val="lt1"/>
-          </a:fontRef>
-        </p:style>
-        <p:txBody>
-          <a:bodyPr rtlCol="0" anchor="ctr"/>
-          <a:lstStyle/>
-          <a:p>
-            <a:pPr algn="ctr"/>
-          </a:p>
-        </p:txBody>
-      </p:sp>
-      <p:sp>
-        <p:nvSpPr>
-          <p:cNvPr id="35" name="Oval 34"/>
-          <p:cNvSpPr/>
-          <p:nvPr/>
-        </p:nvSpPr>
-        <p:spPr>
-          <a:xfrm>
-            <a:off x="1106940" y="1217536"/>
-            <a:ext cx="57150" cy="57150"/>
-          </a:xfrm>
-          <a:prstGeom prst="ellipse">
-            <a:avLst/>
-          </a:prstGeom>
-          <a:solidFill>
-            <a:srgbClr val="7F8F73"/>
-          </a:solidFill>
-          <a:ln>
-            <a:noFill/>
-          </a:ln>
-          <a:effectLst/>
-        </p:spPr>
-        <p:style>
-          <a:lnRef idx="1">
-            <a:schemeClr val="accent1"/>
-          </a:lnRef>
-          <a:fillRef idx="3">
-            <a:schemeClr val="accent1"/>
-          </a:fillRef>
-          <a:effectRef idx="2">
-            <a:schemeClr val="accent1"/>
-          </a:effectRef>
-          <a:fontRef idx="minor">
-            <a:schemeClr val="lt1"/>
-          </a:fontRef>
-        </p:style>
-        <p:txBody>
-          <a:bodyPr rtlCol="0" anchor="ctr"/>
-          <a:lstStyle/>
-          <a:p>
-            <a:pPr algn="ctr"/>
-          </a:p>
-        </p:txBody>
-      </p:sp>
-      <p:sp>
-        <p:nvSpPr>
-          <p:cNvPr id="36" name="Oval 35"/>
-          <p:cNvSpPr/>
-          <p:nvPr/>
-        </p:nvSpPr>
-        <p:spPr>
-          <a:xfrm>
-            <a:off x="1316982" y="1220185"/>
-            <a:ext cx="57150" cy="57150"/>
-          </a:xfrm>
-          <a:prstGeom prst="ellipse">
-            <a:avLst/>
-          </a:prstGeom>
-          <a:solidFill>
-            <a:srgbClr val="7F8F73"/>
-          </a:solidFill>
-          <a:ln>
-            <a:noFill/>
-          </a:ln>
-          <a:effectLst/>
-        </p:spPr>
-        <p:style>
-          <a:lnRef idx="1">
-            <a:schemeClr val="accent1"/>
-          </a:lnRef>
-          <a:fillRef idx="3">
-            <a:schemeClr val="accent1"/>
-          </a:fillRef>
-          <a:effectRef idx="2">
-            <a:schemeClr val="accent1"/>
-          </a:effectRef>
-          <a:fontRef idx="minor">
-            <a:schemeClr val="lt1"/>
-          </a:fontRef>
-        </p:style>
-        <p:txBody>
-          <a:bodyPr rtlCol="0" anchor="ctr"/>
-          <a:lstStyle/>
-          <a:p>
-            <a:pPr algn="ctr"/>
-          </a:p>
-        </p:txBody>
-      </p:sp>
-      <p:sp>
-        <p:nvSpPr>
-          <p:cNvPr id="37" name="Oval 36"/>
-          <p:cNvSpPr/>
-          <p:nvPr/>
-        </p:nvSpPr>
-        <p:spPr>
-          <a:xfrm>
-            <a:off x="8134350" y="228600"/>
-            <a:ext cx="876300" cy="876300"/>
-          </a:xfrm>
-          <a:prstGeom prst="ellipse">
-            <a:avLst/>
-          </a:prstGeom>
-          <a:noFill/>
-          <a:ln w="19050">
-            <a:solidFill>
-              <a:srgbClr val="7F8F73"/>
-            </a:solidFill>
-          </a:ln>
-          <a:effectLst/>
-        </p:spPr>
-        <p:style>
-          <a:lnRef idx="1">
-            <a:schemeClr val="accent1"/>
-          </a:lnRef>
-          <a:fillRef idx="3">
-            <a:schemeClr val="accent1"/>
-          </a:fillRef>
-          <a:effectRef idx="2">
-            <a:schemeClr val="accent1"/>
-          </a:effectRef>
-          <a:fontRef idx="minor">
-            <a:schemeClr val="lt1"/>
-          </a:fontRef>
-        </p:style>
-        <p:txBody>
-          <a:bodyPr rtlCol="0" anchor="ctr"/>
-          <a:lstStyle/>
-          <a:p>
-            <a:pPr algn="ctr"/>
-          </a:p>
-        </p:txBody>
-      </p:sp>
-      <p:sp>
-        <p:nvSpPr>
-          <p:cNvPr id="38" name="Oval 37"/>
-          <p:cNvSpPr/>
-          <p:nvPr/>
-        </p:nvSpPr>
-        <p:spPr>
-          <a:xfrm>
-            <a:off x="8784907" y="638175"/>
-            <a:ext cx="57150" cy="57150"/>
-          </a:xfrm>
-          <a:prstGeom prst="ellipse">
-            <a:avLst/>
-          </a:prstGeom>
-          <a:solidFill>
-            <a:srgbClr val="7F8F73"/>
-          </a:solidFill>
-          <a:ln>
-            <a:noFill/>
-          </a:ln>
-          <a:effectLst/>
-        </p:spPr>
-        <p:style>
-          <a:lnRef idx="1">
-            <a:schemeClr val="accent1"/>
-          </a:lnRef>
-          <a:fillRef idx="3">
-            <a:schemeClr val="accent1"/>
-          </a:fillRef>
-          <a:effectRef idx="2">
-            <a:schemeClr val="accent1"/>
-          </a:effectRef>
-          <a:fontRef idx="minor">
-            <a:schemeClr val="lt1"/>
-          </a:fontRef>
-        </p:style>
-        <p:txBody>
-          <a:bodyPr rtlCol="0" anchor="ctr"/>
-          <a:lstStyle/>
-          <a:p>
-            <a:pPr algn="ctr"/>
-          </a:p>
-        </p:txBody>
-      </p:sp>
-      <p:sp>
-        <p:nvSpPr>
-          <p:cNvPr id="39" name="Oval 38"/>
-          <p:cNvSpPr/>
-          <p:nvPr/>
-        </p:nvSpPr>
-        <p:spPr>
-          <a:xfrm>
-            <a:off x="8663830" y="847208"/>
-            <a:ext cx="57150" cy="57150"/>
-          </a:xfrm>
-          <a:prstGeom prst="ellipse">
-            <a:avLst/>
-          </a:prstGeom>
-          <a:solidFill>
-            <a:srgbClr val="7F8F73"/>
-          </a:solidFill>
-          <a:ln>
-            <a:noFill/>
-          </a:ln>
-          <a:effectLst/>
-        </p:spPr>
-        <p:style>
-          <a:lnRef idx="1">
-            <a:schemeClr val="accent1"/>
-          </a:lnRef>
-          <a:fillRef idx="3">
-            <a:schemeClr val="accent1"/>
-          </a:fillRef>
-          <a:effectRef idx="2">
-            <a:schemeClr val="accent1"/>
-          </a:effectRef>
-          <a:fontRef idx="minor">
-            <a:schemeClr val="lt1"/>
-          </a:fontRef>
-        </p:style>
-        <p:txBody>
-          <a:bodyPr rtlCol="0" anchor="ctr"/>
-          <a:lstStyle/>
-          <a:p>
-            <a:pPr algn="ctr"/>
-          </a:p>
-        </p:txBody>
-      </p:sp>
-      <p:sp>
-        <p:nvSpPr>
-          <p:cNvPr id="40" name="Oval 39"/>
-          <p:cNvSpPr/>
-          <p:nvPr/>
-        </p:nvSpPr>
-        <p:spPr>
-          <a:xfrm>
-            <a:off x="8422265" y="846193"/>
-            <a:ext cx="57150" cy="57150"/>
-          </a:xfrm>
-          <a:prstGeom prst="ellipse">
-            <a:avLst/>
-          </a:prstGeom>
-          <a:solidFill>
-            <a:srgbClr val="7F8F73"/>
-          </a:solidFill>
-          <a:ln>
-            <a:noFill/>
-          </a:ln>
-          <a:effectLst/>
-        </p:spPr>
-        <p:style>
-          <a:lnRef idx="1">
-            <a:schemeClr val="accent1"/>
-          </a:lnRef>
-          <a:fillRef idx="3">
-            <a:schemeClr val="accent1"/>
-          </a:fillRef>
-          <a:effectRef idx="2">
-            <a:schemeClr val="accent1"/>
-          </a:effectRef>
-          <a:fontRef idx="minor">
-            <a:schemeClr val="lt1"/>
-          </a:fontRef>
-        </p:style>
-        <p:txBody>
-          <a:bodyPr rtlCol="0" anchor="ctr"/>
-          <a:lstStyle/>
-          <a:p>
-            <a:pPr algn="ctr"/>
-          </a:p>
-        </p:txBody>
-      </p:sp>
-      <p:sp>
-        <p:nvSpPr>
-          <p:cNvPr id="41" name="Oval 40"/>
-          <p:cNvSpPr/>
-          <p:nvPr/>
-        </p:nvSpPr>
-        <p:spPr>
-          <a:xfrm>
-            <a:off x="8302951" y="636149"/>
-            <a:ext cx="57150" cy="57150"/>
-          </a:xfrm>
-          <a:prstGeom prst="ellipse">
-            <a:avLst/>
-          </a:prstGeom>
-          <a:solidFill>
-            <a:srgbClr val="7F8F73"/>
-          </a:solidFill>
-          <a:ln>
-            <a:noFill/>
-          </a:ln>
-          <a:effectLst/>
-        </p:spPr>
-        <p:style>
-          <a:lnRef idx="1">
-            <a:schemeClr val="accent1"/>
-          </a:lnRef>
-          <a:fillRef idx="3">
-            <a:schemeClr val="accent1"/>
-          </a:fillRef>
-          <a:effectRef idx="2">
-            <a:schemeClr val="accent1"/>
-          </a:effectRef>
-          <a:fontRef idx="minor">
-            <a:schemeClr val="lt1"/>
-          </a:fontRef>
-        </p:style>
-        <p:txBody>
-          <a:bodyPr rtlCol="0" anchor="ctr"/>
-          <a:lstStyle/>
-          <a:p>
-            <a:pPr algn="ctr"/>
-          </a:p>
-        </p:txBody>
-      </p:sp>
-      <p:sp>
-        <p:nvSpPr>
-          <p:cNvPr id="42" name="Oval 41"/>
-          <p:cNvSpPr/>
-          <p:nvPr/>
-        </p:nvSpPr>
-        <p:spPr>
-          <a:xfrm>
-            <a:off x="8425780" y="428140"/>
-            <a:ext cx="57150" cy="57150"/>
-          </a:xfrm>
-          <a:prstGeom prst="ellipse">
-            <a:avLst/>
-          </a:prstGeom>
-          <a:solidFill>
-            <a:srgbClr val="7F8F73"/>
-          </a:solidFill>
-          <a:ln>
-            <a:noFill/>
-          </a:ln>
-          <a:effectLst/>
-        </p:spPr>
-        <p:style>
-          <a:lnRef idx="1">
-            <a:schemeClr val="accent1"/>
-          </a:lnRef>
-          <a:fillRef idx="3">
-            <a:schemeClr val="accent1"/>
-          </a:fillRef>
-          <a:effectRef idx="2">
-            <a:schemeClr val="accent1"/>
-          </a:effectRef>
-          <a:fontRef idx="minor">
-            <a:schemeClr val="lt1"/>
-          </a:fontRef>
-        </p:style>
-        <p:txBody>
-          <a:bodyPr rtlCol="0" anchor="ctr"/>
-          <a:lstStyle/>
-          <a:p>
-            <a:pPr algn="ctr"/>
-          </a:p>
-        </p:txBody>
-      </p:sp>
-      <p:sp>
-        <p:nvSpPr>
-          <p:cNvPr id="43" name="Oval 42"/>
-          <p:cNvSpPr/>
-          <p:nvPr/>
-        </p:nvSpPr>
-        <p:spPr>
-          <a:xfrm>
-            <a:off x="8667328" y="431186"/>
-            <a:ext cx="57150" cy="57150"/>
-          </a:xfrm>
-          <a:prstGeom prst="ellipse">
-            <a:avLst/>
-          </a:prstGeom>
-          <a:solidFill>
-            <a:srgbClr val="7F8F73"/>
-          </a:solidFill>
-          <a:ln>
-            <a:noFill/>
-          </a:ln>
-          <a:effectLst/>
-        </p:spPr>
-        <p:style>
-          <a:lnRef idx="1">
-            <a:schemeClr val="accent1"/>
-          </a:lnRef>
-          <a:fillRef idx="3">
-            <a:schemeClr val="accent1"/>
-          </a:fillRef>
-          <a:effectRef idx="2">
-            <a:schemeClr val="accent1"/>
-          </a:effectRef>
-          <a:fontRef idx="minor">
-            <a:schemeClr val="lt1"/>
-          </a:fontRef>
-        </p:style>
-        <p:txBody>
-          <a:bodyPr rtlCol="0" anchor="ctr"/>
-          <a:lstStyle/>
-          <a:p>
-            <a:pPr algn="ctr"/>
-          </a:p>
-        </p:txBody>
-      </p:sp>
-      <p:sp>
-        <p:nvSpPr>
-          <p:cNvPr id="44" name="Freeform 43"/>
-          <p:cNvSpPr/>
-          <p:nvPr/>
-        </p:nvSpPr>
-        <p:spPr>
-          <a:xfrm>
-            <a:off x="4476750" y="6759530"/>
-            <a:ext cx="5810250" cy="4956219"/>
-          </a:xfrm>
-          <a:custGeom>
-            <a:avLst/>
-            <a:gdLst/>
-            <a:ahLst/>
-            <a:cxnLst/>
-            <a:rect l="l" t="t" r="r" b="b"/>
-            <a:pathLst>
-              <a:path w="5810250" h="4956220">
-                <a:moveTo>
-                  <a:pt x="0" y="860470"/>
-                </a:moveTo>
-                <a:lnTo>
-                  <a:pt x="190500" y="954580"/>
-                </a:lnTo>
-                <a:lnTo>
-                  <a:pt x="381000" y="1045079"/>
-                </a:lnTo>
-                <a:lnTo>
-                  <a:pt x="571500" y="1128480"/>
-                </a:lnTo>
-                <a:lnTo>
-                  <a:pt x="762000" y="1201539"/>
-                </a:lnTo>
-                <a:lnTo>
-                  <a:pt x="952500" y="1261365"/>
-                </a:lnTo>
-                <a:lnTo>
-                  <a:pt x="1143000" y="1305522"/>
-                </a:lnTo>
-                <a:lnTo>
-                  <a:pt x="1333500" y="1332113"/>
-                </a:lnTo>
-                <a:lnTo>
-                  <a:pt x="1524000" y="1339840"/>
-                </a:lnTo>
-                <a:lnTo>
-                  <a:pt x="1714500" y="1328052"/>
-                </a:lnTo>
-                <a:lnTo>
-                  <a:pt x="1905000" y="1296769"/>
-                </a:lnTo>
-                <a:lnTo>
-                  <a:pt x="2095500" y="1246677"/>
-                </a:lnTo>
-                <a:lnTo>
-                  <a:pt x="2286000" y="1179109"/>
-                </a:lnTo>
-                <a:lnTo>
-                  <a:pt x="2476500" y="1095994"/>
-                </a:lnTo>
-                <a:lnTo>
-                  <a:pt x="2667000" y="999796"/>
-                </a:lnTo>
-                <a:lnTo>
-                  <a:pt x="2857500" y="893428"/>
-                </a:lnTo>
-                <a:lnTo>
-                  <a:pt x="3048000" y="780150"/>
-                </a:lnTo>
-                <a:lnTo>
-                  <a:pt x="3238500" y="663458"/>
-                </a:lnTo>
-                <a:lnTo>
-                  <a:pt x="3429000" y="546969"/>
-                </a:lnTo>
-                <a:lnTo>
-                  <a:pt x="3619500" y="434289"/>
-                </a:lnTo>
-                <a:lnTo>
-                  <a:pt x="3810000" y="328895"/>
-                </a:lnTo>
-                <a:lnTo>
-                  <a:pt x="4000500" y="234015"/>
-                </a:lnTo>
-                <a:lnTo>
-                  <a:pt x="4191000" y="152515"/>
-                </a:lnTo>
-                <a:lnTo>
-                  <a:pt x="4381500" y="86803"/>
-                </a:lnTo>
-                <a:lnTo>
-                  <a:pt x="4572000" y="38747"/>
-                </a:lnTo>
-                <a:lnTo>
-                  <a:pt x="4762500" y="9608"/>
-                </a:lnTo>
-                <a:lnTo>
-                  <a:pt x="4953000" y="0"/>
-                </a:lnTo>
-                <a:lnTo>
-                  <a:pt x="5143500" y="9867"/>
-                </a:lnTo>
-                <a:lnTo>
-                  <a:pt x="5334000" y="38485"/>
-                </a:lnTo>
-                <a:lnTo>
-                  <a:pt x="5524500" y="84488"/>
-                </a:lnTo>
-                <a:lnTo>
-                  <a:pt x="5715000" y="145914"/>
-                </a:lnTo>
-                <a:lnTo>
-                  <a:pt x="5810250" y="4956220"/>
-                </a:lnTo>
-                <a:lnTo>
-                  <a:pt x="0" y="4956220"/>
-                </a:lnTo>
-                <a:close/>
-              </a:path>
-            </a:pathLst>
-          </a:custGeom>
-          <a:solidFill>
-            <a:srgbClr val="C9D3BC"/>
-          </a:solidFill>
-          <a:ln>
-            <a:noFill/>
-          </a:ln>
-          <a:effectLst/>
-        </p:spPr>
-        <p:style>
-          <a:lnRef idx="1">
-            <a:schemeClr val="accent1"/>
-          </a:lnRef>
-          <a:fillRef idx="3">
-            <a:schemeClr val="accent1"/>
-          </a:fillRef>
-          <a:effectRef idx="2">
-            <a:schemeClr val="accent1"/>
-          </a:effectRef>
-          <a:fontRef idx="minor">
-            <a:schemeClr val="lt1"/>
-          </a:fontRef>
-        </p:style>
-        <p:txBody>
-          <a:bodyPr rtlCol="0" anchor="ctr"/>
-          <a:lstStyle/>
-          <a:p>
-            <a:pPr algn="ctr"/>
-          </a:p>
-        </p:txBody>
-      </p:sp>
-      <p:sp>
-        <p:nvSpPr>
-          <p:cNvPr id="45" name="Rounded Rectangle 44"/>
-          <p:cNvSpPr/>
-          <p:nvPr/>
-        </p:nvSpPr>
-        <p:spPr>
-          <a:xfrm>
-            <a:off x="5280660" y="9667875"/>
-            <a:ext cx="106680" cy="2000250"/>
-          </a:xfrm>
-          <a:prstGeom prst="roundRect">
-            <a:avLst>
-              <a:gd name="adj" fmla="val 50000"/>
-            </a:avLst>
-          </a:prstGeom>
-          <a:noFill/>
-          <a:ln w="19050">
-            <a:solidFill>
-              <a:srgbClr val="7F8F73"/>
-            </a:solidFill>
-          </a:ln>
-          <a:effectLst/>
-        </p:spPr>
-        <p:style>
-          <a:lnRef idx="1">
-            <a:schemeClr val="accent1"/>
-          </a:lnRef>
-          <a:fillRef idx="3">
-            <a:schemeClr val="accent1"/>
-          </a:fillRef>
-          <a:effectRef idx="2">
-            <a:schemeClr val="accent1"/>
-          </a:effectRef>
-          <a:fontRef idx="minor">
-            <a:schemeClr val="lt1"/>
-          </a:fontRef>
-        </p:style>
-        <p:txBody>
-          <a:bodyPr rtlCol="0" anchor="ctr"/>
-          <a:lstStyle/>
-          <a:p>
-            <a:pPr algn="ctr"/>
-          </a:p>
-        </p:txBody>
-      </p:sp>
-      <p:sp>
-        <p:nvSpPr>
-          <p:cNvPr id="46" name="Round Same Side Corner Rectangle 45"/>
-          <p:cNvSpPr/>
-          <p:nvPr/>
-        </p:nvSpPr>
-        <p:spPr>
-          <a:xfrm>
-            <a:off x="5000625" y="9466183"/>
-            <a:ext cx="666750" cy="366712"/>
-          </a:xfrm>
-          <a:prstGeom prst="round2SameRect">
-            <a:avLst>
-              <a:gd name="adj1" fmla="val 50000"/>
-              <a:gd name="adj2" fmla="val 0"/>
-            </a:avLst>
-          </a:prstGeom>
-          <a:noFill/>
-          <a:ln w="19050">
-            <a:solidFill>
-              <a:srgbClr val="7F8F73"/>
-            </a:solidFill>
-          </a:ln>
-          <a:effectLst/>
-        </p:spPr>
-        <p:style>
-          <a:lnRef idx="1">
-            <a:schemeClr val="accent1"/>
-          </a:lnRef>
-          <a:fillRef idx="3">
-            <a:schemeClr val="accent1"/>
-          </a:fillRef>
-          <a:effectRef idx="2">
-            <a:schemeClr val="accent1"/>
-          </a:effectRef>
-          <a:fontRef idx="minor">
-            <a:schemeClr val="lt1"/>
-          </a:fontRef>
-        </p:style>
-        <p:txBody>
-          <a:bodyPr rtlCol="0" anchor="ctr"/>
-          <a:lstStyle/>
-          <a:p>
-            <a:pPr algn="ctr"/>
-          </a:p>
-        </p:txBody>
-      </p:sp>
-      <p:sp>
-        <p:nvSpPr>
-          <p:cNvPr id="47" name="Rectangle 46"/>
-          <p:cNvSpPr/>
-          <p:nvPr/>
-        </p:nvSpPr>
-        <p:spPr>
-          <a:xfrm>
-            <a:off x="5057775" y="9667875"/>
-            <a:ext cx="552450" cy="57150"/>
-          </a:xfrm>
-          <a:prstGeom prst="rect">
-            <a:avLst/>
-          </a:prstGeom>
-          <a:noFill/>
-          <a:ln w="19050">
-            <a:solidFill>
-              <a:srgbClr val="7F8F73"/>
-            </a:solidFill>
-          </a:ln>
-          <a:effectLst/>
-        </p:spPr>
-        <p:style>
-          <a:lnRef idx="1">
-            <a:schemeClr val="accent1"/>
-          </a:lnRef>
-          <a:fillRef idx="3">
-            <a:schemeClr val="accent1"/>
-          </a:fillRef>
-          <a:effectRef idx="2">
-            <a:schemeClr val="accent1"/>
-          </a:effectRef>
-          <a:fontRef idx="minor">
-            <a:schemeClr val="lt1"/>
-          </a:fontRef>
-        </p:style>
-        <p:txBody>
-          <a:bodyPr rtlCol="0" anchor="ctr"/>
-          <a:lstStyle/>
-          <a:p>
-            <a:pPr algn="ctr"/>
-          </a:p>
-        </p:txBody>
-      </p:sp>
-      <p:sp>
-        <p:nvSpPr>
-          <p:cNvPr id="48" name="Rounded Rectangle 47"/>
-          <p:cNvSpPr/>
-          <p:nvPr/>
-        </p:nvSpPr>
-        <p:spPr>
-          <a:xfrm>
-            <a:off x="6027420" y="8810625"/>
-            <a:ext cx="137160" cy="2857500"/>
-          </a:xfrm>
-          <a:prstGeom prst="roundRect">
-            <a:avLst>
-              <a:gd name="adj" fmla="val 50000"/>
-            </a:avLst>
-          </a:prstGeom>
-          <a:noFill/>
-          <a:ln w="19050">
-            <a:solidFill>
-              <a:srgbClr val="7F8F73"/>
-            </a:solidFill>
-          </a:ln>
-          <a:effectLst/>
-        </p:spPr>
-        <p:style>
-          <a:lnRef idx="1">
-            <a:schemeClr val="accent1"/>
-          </a:lnRef>
-          <a:fillRef idx="3">
-            <a:schemeClr val="accent1"/>
-          </a:fillRef>
-          <a:effectRef idx="2">
-            <a:schemeClr val="accent1"/>
-          </a:effectRef>
-          <a:fontRef idx="minor">
-            <a:schemeClr val="lt1"/>
-          </a:fontRef>
-        </p:style>
-        <p:txBody>
-          <a:bodyPr rtlCol="0" anchor="ctr"/>
-          <a:lstStyle/>
-          <a:p>
-            <a:pPr algn="ctr"/>
-          </a:p>
-        </p:txBody>
-      </p:sp>
-      <p:sp>
-        <p:nvSpPr>
-          <p:cNvPr id="49" name="Round Same Side Corner Rectangle 48"/>
-          <p:cNvSpPr/>
-          <p:nvPr/>
-        </p:nvSpPr>
-        <p:spPr>
-          <a:xfrm>
-            <a:off x="5667375" y="8551306"/>
-            <a:ext cx="857250" cy="471487"/>
-          </a:xfrm>
-          <a:prstGeom prst="round2SameRect">
-            <a:avLst>
-              <a:gd name="adj1" fmla="val 50000"/>
-              <a:gd name="adj2" fmla="val 0"/>
-            </a:avLst>
-          </a:prstGeom>
-          <a:noFill/>
-          <a:ln w="19050">
-            <a:solidFill>
-              <a:srgbClr val="7F8F73"/>
-            </a:solidFill>
-          </a:ln>
-          <a:effectLst/>
-        </p:spPr>
-        <p:style>
-          <a:lnRef idx="1">
-            <a:schemeClr val="accent1"/>
-          </a:lnRef>
-          <a:fillRef idx="3">
-            <a:schemeClr val="accent1"/>
-          </a:fillRef>
-          <a:effectRef idx="2">
-            <a:schemeClr val="accent1"/>
-          </a:effectRef>
-          <a:fontRef idx="minor">
-            <a:schemeClr val="lt1"/>
-          </a:fontRef>
-        </p:style>
-        <p:txBody>
-          <a:bodyPr rtlCol="0" anchor="ctr"/>
-          <a:lstStyle/>
-          <a:p>
-            <a:pPr algn="ctr"/>
-          </a:p>
-        </p:txBody>
-      </p:sp>
-      <p:sp>
-        <p:nvSpPr>
-          <p:cNvPr id="50" name="Rectangle 49"/>
-          <p:cNvSpPr/>
-          <p:nvPr/>
-        </p:nvSpPr>
-        <p:spPr>
-          <a:xfrm>
-            <a:off x="5724525" y="8810625"/>
-            <a:ext cx="742950" cy="57150"/>
-          </a:xfrm>
-          <a:prstGeom prst="rect">
-            <a:avLst/>
-          </a:prstGeom>
-          <a:noFill/>
-          <a:ln w="19050">
-            <a:solidFill>
-              <a:srgbClr val="7F8F73"/>
-            </a:solidFill>
-          </a:ln>
-          <a:effectLst/>
-        </p:spPr>
-        <p:style>
-          <a:lnRef idx="1">
-            <a:schemeClr val="accent1"/>
-          </a:lnRef>
-          <a:fillRef idx="3">
-            <a:schemeClr val="accent1"/>
-          </a:fillRef>
-          <a:effectRef idx="2">
-            <a:schemeClr val="accent1"/>
-          </a:effectRef>
-          <a:fontRef idx="minor">
-            <a:schemeClr val="lt1"/>
-          </a:fontRef>
-        </p:style>
-        <p:txBody>
-          <a:bodyPr rtlCol="0" anchor="ctr"/>
-          <a:lstStyle/>
-          <a:p>
-            <a:pPr algn="ctr"/>
-          </a:p>
-        </p:txBody>
-      </p:sp>
-      <p:sp>
-        <p:nvSpPr>
-          <p:cNvPr id="51" name="Rounded Rectangle 50"/>
-          <p:cNvSpPr/>
-          <p:nvPr/>
-        </p:nvSpPr>
-        <p:spPr>
-          <a:xfrm>
-            <a:off x="6804660" y="9382125"/>
-            <a:ext cx="106680" cy="2286000"/>
-          </a:xfrm>
-          <a:prstGeom prst="roundRect">
-            <a:avLst>
-              <a:gd name="adj" fmla="val 50000"/>
-            </a:avLst>
-          </a:prstGeom>
-          <a:noFill/>
-          <a:ln w="19050">
-            <a:solidFill>
-              <a:srgbClr val="7F8F73"/>
-            </a:solidFill>
-          </a:ln>
-          <a:effectLst/>
-        </p:spPr>
-        <p:style>
-          <a:lnRef idx="1">
-            <a:schemeClr val="accent1"/>
-          </a:lnRef>
-          <a:fillRef idx="3">
-            <a:schemeClr val="accent1"/>
-          </a:fillRef>
-          <a:effectRef idx="2">
-            <a:schemeClr val="accent1"/>
-          </a:effectRef>
-          <a:fontRef idx="minor">
-            <a:schemeClr val="lt1"/>
-          </a:fontRef>
-        </p:style>
-        <p:txBody>
-          <a:bodyPr rtlCol="0" anchor="ctr"/>
-          <a:lstStyle/>
-          <a:p>
-            <a:pPr algn="ctr"/>
-          </a:p>
-        </p:txBody>
-      </p:sp>
-      <p:sp>
-        <p:nvSpPr>
-          <p:cNvPr id="52" name="Round Same Side Corner Rectangle 51"/>
-          <p:cNvSpPr/>
-          <p:nvPr/>
-        </p:nvSpPr>
-        <p:spPr>
-          <a:xfrm>
-            <a:off x="6524625" y="9180433"/>
-            <a:ext cx="666750" cy="366712"/>
-          </a:xfrm>
-          <a:prstGeom prst="round2SameRect">
-            <a:avLst>
-              <a:gd name="adj1" fmla="val 50000"/>
-              <a:gd name="adj2" fmla="val 0"/>
-            </a:avLst>
-          </a:prstGeom>
-          <a:noFill/>
-          <a:ln w="19050">
-            <a:solidFill>
-              <a:srgbClr val="7F8F73"/>
-            </a:solidFill>
-          </a:ln>
-          <a:effectLst/>
-        </p:spPr>
-        <p:style>
-          <a:lnRef idx="1">
-            <a:schemeClr val="accent1"/>
-          </a:lnRef>
-          <a:fillRef idx="3">
-            <a:schemeClr val="accent1"/>
-          </a:fillRef>
-          <a:effectRef idx="2">
-            <a:schemeClr val="accent1"/>
-          </a:effectRef>
-          <a:fontRef idx="minor">
-            <a:schemeClr val="lt1"/>
-          </a:fontRef>
-        </p:style>
-        <p:txBody>
-          <a:bodyPr rtlCol="0" anchor="ctr"/>
-          <a:lstStyle/>
-          <a:p>
-            <a:pPr algn="ctr"/>
-          </a:p>
-        </p:txBody>
-      </p:sp>
-      <p:sp>
-        <p:nvSpPr>
-          <p:cNvPr id="53" name="Rectangle 52"/>
-          <p:cNvSpPr/>
-          <p:nvPr/>
-        </p:nvSpPr>
-        <p:spPr>
-          <a:xfrm>
-            <a:off x="6581775" y="9382125"/>
-            <a:ext cx="552450" cy="57150"/>
-          </a:xfrm>
-          <a:prstGeom prst="rect">
-            <a:avLst/>
-          </a:prstGeom>
-          <a:noFill/>
-          <a:ln w="19050">
-            <a:solidFill>
-              <a:srgbClr val="7F8F73"/>
-            </a:solidFill>
-          </a:ln>
-          <a:effectLst/>
-        </p:spPr>
-        <p:style>
-          <a:lnRef idx="1">
-            <a:schemeClr val="accent1"/>
-          </a:lnRef>
-          <a:fillRef idx="3">
-            <a:schemeClr val="accent1"/>
-          </a:fillRef>
-          <a:effectRef idx="2">
-            <a:schemeClr val="accent1"/>
-          </a:effectRef>
-          <a:fontRef idx="minor">
-            <a:schemeClr val="lt1"/>
-          </a:fontRef>
-        </p:style>
-        <p:txBody>
-          <a:bodyPr rtlCol="0" anchor="ctr"/>
-          <a:lstStyle/>
-          <a:p>
-            <a:pPr algn="ctr"/>
-          </a:p>
-        </p:txBody>
-      </p:sp>
-      <p:sp>
-        <p:nvSpPr>
-          <p:cNvPr id="54" name="Rounded Rectangle 53"/>
-          <p:cNvSpPr/>
-          <p:nvPr/>
-        </p:nvSpPr>
-        <p:spPr>
-          <a:xfrm>
-            <a:off x="7543800" y="8524875"/>
-            <a:ext cx="152400" cy="3143250"/>
-          </a:xfrm>
-          <a:prstGeom prst="roundRect">
-            <a:avLst>
-              <a:gd name="adj" fmla="val 50000"/>
-            </a:avLst>
-          </a:prstGeom>
-          <a:noFill/>
-          <a:ln w="19050">
-            <a:solidFill>
-              <a:srgbClr val="7F8F73"/>
-            </a:solidFill>
-          </a:ln>
-          <a:effectLst/>
-        </p:spPr>
-        <p:style>
-          <a:lnRef idx="1">
-            <a:schemeClr val="accent1"/>
-          </a:lnRef>
-          <a:fillRef idx="3">
-            <a:schemeClr val="accent1"/>
-          </a:fillRef>
-          <a:effectRef idx="2">
-            <a:schemeClr val="accent1"/>
-          </a:effectRef>
-          <a:fontRef idx="minor">
-            <a:schemeClr val="lt1"/>
-          </a:fontRef>
-        </p:style>
-        <p:txBody>
-          <a:bodyPr rtlCol="0" anchor="ctr"/>
-          <a:lstStyle/>
-          <a:p>
-            <a:pPr algn="ctr"/>
-          </a:p>
-        </p:txBody>
-      </p:sp>
-      <p:sp>
-        <p:nvSpPr>
-          <p:cNvPr id="55" name="Round Same Side Corner Rectangle 54"/>
-          <p:cNvSpPr/>
-          <p:nvPr/>
-        </p:nvSpPr>
-        <p:spPr>
-          <a:xfrm>
-            <a:off x="7143750" y="8236743"/>
-            <a:ext cx="952500" cy="523875"/>
-          </a:xfrm>
-          <a:prstGeom prst="round2SameRect">
-            <a:avLst>
-              <a:gd name="adj1" fmla="val 50000"/>
-              <a:gd name="adj2" fmla="val 0"/>
-            </a:avLst>
-          </a:prstGeom>
-          <a:noFill/>
-          <a:ln w="19050">
-            <a:solidFill>
-              <a:srgbClr val="7F8F73"/>
-            </a:solidFill>
-          </a:ln>
-          <a:effectLst/>
-        </p:spPr>
-        <p:style>
-          <a:lnRef idx="1">
-            <a:schemeClr val="accent1"/>
-          </a:lnRef>
-          <a:fillRef idx="3">
-            <a:schemeClr val="accent1"/>
-          </a:fillRef>
-          <a:effectRef idx="2">
-            <a:schemeClr val="accent1"/>
-          </a:effectRef>
-          <a:fontRef idx="minor">
-            <a:schemeClr val="lt1"/>
-          </a:fontRef>
-        </p:style>
-        <p:txBody>
-          <a:bodyPr rtlCol="0" anchor="ctr"/>
-          <a:lstStyle/>
-          <a:p>
-            <a:pPr algn="ctr"/>
-          </a:p>
-        </p:txBody>
-      </p:sp>
-      <p:sp>
-        <p:nvSpPr>
-          <p:cNvPr id="56" name="Rectangle 55"/>
-          <p:cNvSpPr/>
-          <p:nvPr/>
-        </p:nvSpPr>
-        <p:spPr>
-          <a:xfrm>
-            <a:off x="7200900" y="8524875"/>
-            <a:ext cx="838200" cy="57150"/>
-          </a:xfrm>
-          <a:prstGeom prst="rect">
-            <a:avLst/>
-          </a:prstGeom>
-          <a:noFill/>
-          <a:ln w="19050">
-            <a:solidFill>
-              <a:srgbClr val="7F8F73"/>
-            </a:solidFill>
-          </a:ln>
-          <a:effectLst/>
-        </p:spPr>
-        <p:style>
-          <a:lnRef idx="1">
-            <a:schemeClr val="accent1"/>
-          </a:lnRef>
-          <a:fillRef idx="3">
-            <a:schemeClr val="accent1"/>
-          </a:fillRef>
-          <a:effectRef idx="2">
-            <a:schemeClr val="accent1"/>
-          </a:effectRef>
-          <a:fontRef idx="minor">
-            <a:schemeClr val="lt1"/>
-          </a:fontRef>
-        </p:style>
-        <p:txBody>
-          <a:bodyPr rtlCol="0" anchor="ctr"/>
-          <a:lstStyle/>
-          <a:p>
-            <a:pPr algn="ctr"/>
-          </a:p>
-        </p:txBody>
-      </p:sp>
-      <p:sp>
-        <p:nvSpPr>
-          <p:cNvPr id="57" name="Rounded Rectangle 56"/>
-          <p:cNvSpPr/>
-          <p:nvPr/>
-        </p:nvSpPr>
-        <p:spPr>
-          <a:xfrm>
-            <a:off x="8321040" y="9191625"/>
-            <a:ext cx="121920" cy="2476500"/>
-          </a:xfrm>
-          <a:prstGeom prst="roundRect">
-            <a:avLst>
-              <a:gd name="adj" fmla="val 50000"/>
-            </a:avLst>
-          </a:prstGeom>
-          <a:noFill/>
-          <a:ln w="19050">
-            <a:solidFill>
-              <a:srgbClr val="7F8F73"/>
-            </a:solidFill>
-          </a:ln>
-          <a:effectLst/>
-        </p:spPr>
-        <p:style>
-          <a:lnRef idx="1">
-            <a:schemeClr val="accent1"/>
-          </a:lnRef>
-          <a:fillRef idx="3">
-            <a:schemeClr val="accent1"/>
-          </a:fillRef>
-          <a:effectRef idx="2">
-            <a:schemeClr val="accent1"/>
-          </a:effectRef>
-          <a:fontRef idx="minor">
-            <a:schemeClr val="lt1"/>
-          </a:fontRef>
-        </p:style>
-        <p:txBody>
-          <a:bodyPr rtlCol="0" anchor="ctr"/>
-          <a:lstStyle/>
-          <a:p>
-            <a:pPr algn="ctr"/>
-          </a:p>
-        </p:txBody>
-      </p:sp>
-      <p:sp>
-        <p:nvSpPr>
-          <p:cNvPr id="58" name="Round Same Side Corner Rectangle 57"/>
-          <p:cNvSpPr/>
-          <p:nvPr/>
-        </p:nvSpPr>
-        <p:spPr>
-          <a:xfrm>
-            <a:off x="8001000" y="8961120"/>
-            <a:ext cx="762000" cy="419100"/>
-          </a:xfrm>
-          <a:prstGeom prst="round2SameRect">
-            <a:avLst>
-              <a:gd name="adj1" fmla="val 50000"/>
-              <a:gd name="adj2" fmla="val 0"/>
-            </a:avLst>
-          </a:prstGeom>
-          <a:noFill/>
-          <a:ln w="19050">
-            <a:solidFill>
-              <a:srgbClr val="7F8F73"/>
-            </a:solidFill>
-          </a:ln>
-          <a:effectLst/>
-        </p:spPr>
-        <p:style>
-          <a:lnRef idx="1">
-            <a:schemeClr val="accent1"/>
-          </a:lnRef>
-          <a:fillRef idx="3">
-            <a:schemeClr val="accent1"/>
-          </a:fillRef>
-          <a:effectRef idx="2">
-            <a:schemeClr val="accent1"/>
-          </a:effectRef>
-          <a:fontRef idx="minor">
-            <a:schemeClr val="lt1"/>
-          </a:fontRef>
-        </p:style>
-        <p:txBody>
-          <a:bodyPr rtlCol="0" anchor="ctr"/>
-          <a:lstStyle/>
-          <a:p>
-            <a:pPr algn="ctr"/>
-          </a:p>
-        </p:txBody>
-      </p:sp>
-      <p:sp>
-        <p:nvSpPr>
-          <p:cNvPr id="59" name="Rectangle 58"/>
-          <p:cNvSpPr/>
-          <p:nvPr/>
-        </p:nvSpPr>
-        <p:spPr>
-          <a:xfrm>
-            <a:off x="8058150" y="9191625"/>
-            <a:ext cx="647700" cy="57150"/>
-          </a:xfrm>
-          <a:prstGeom prst="rect">
-            <a:avLst/>
-          </a:prstGeom>
-          <a:noFill/>
-          <a:ln w="19050">
-            <a:solidFill>
-              <a:srgbClr val="7F8F73"/>
-            </a:solidFill>
-          </a:ln>
-          <a:effectLst/>
-        </p:spPr>
-        <p:style>
-          <a:lnRef idx="1">
-            <a:schemeClr val="accent1"/>
-          </a:lnRef>
-          <a:fillRef idx="3">
-            <a:schemeClr val="accent1"/>
-          </a:fillRef>
-          <a:effectRef idx="2">
-            <a:schemeClr val="accent1"/>
-          </a:effectRef>
-          <a:fontRef idx="minor">
-            <a:schemeClr val="lt1"/>
-          </a:fontRef>
-        </p:style>
-        <p:txBody>
-          <a:bodyPr rtlCol="0" anchor="ctr"/>
-          <a:lstStyle/>
-          <a:p>
-            <a:pPr algn="ctr"/>
-          </a:p>
-        </p:txBody>
-      </p:sp>
-      <p:sp>
-        <p:nvSpPr>
-          <p:cNvPr id="60" name="Rounded Rectangle 59"/>
-          <p:cNvSpPr/>
-          <p:nvPr/>
-        </p:nvSpPr>
-        <p:spPr>
-          <a:xfrm>
-            <a:off x="9093708" y="9858375"/>
-            <a:ext cx="100584" cy="1809750"/>
-          </a:xfrm>
-          <a:prstGeom prst="roundRect">
-            <a:avLst>
-              <a:gd name="adj" fmla="val 50000"/>
-            </a:avLst>
-          </a:prstGeom>
-          <a:noFill/>
-          <a:ln w="19050">
-            <a:solidFill>
-              <a:srgbClr val="7F8F73"/>
-            </a:solidFill>
-          </a:ln>
-          <a:effectLst/>
-        </p:spPr>
-        <p:style>
-          <a:lnRef idx="1">
-            <a:schemeClr val="accent1"/>
-          </a:lnRef>
-          <a:fillRef idx="3">
-            <a:schemeClr val="accent1"/>
-          </a:fillRef>
-          <a:effectRef idx="2">
-            <a:schemeClr val="accent1"/>
-          </a:effectRef>
-          <a:fontRef idx="minor">
-            <a:schemeClr val="lt1"/>
-          </a:fontRef>
-        </p:style>
-        <p:txBody>
-          <a:bodyPr rtlCol="0" anchor="ctr"/>
-          <a:lstStyle/>
-          <a:p>
-            <a:pPr algn="ctr"/>
-          </a:p>
-        </p:txBody>
-      </p:sp>
-      <p:sp>
-        <p:nvSpPr>
-          <p:cNvPr id="61" name="Round Same Side Corner Rectangle 60"/>
-          <p:cNvSpPr/>
-          <p:nvPr/>
-        </p:nvSpPr>
-        <p:spPr>
-          <a:xfrm>
-            <a:off x="8829675" y="9668208"/>
-            <a:ext cx="628650" cy="345757"/>
-          </a:xfrm>
-          <a:prstGeom prst="round2SameRect">
-            <a:avLst>
-              <a:gd name="adj1" fmla="val 50000"/>
-              <a:gd name="adj2" fmla="val 0"/>
-            </a:avLst>
-          </a:prstGeom>
-          <a:noFill/>
-          <a:ln w="19050">
-            <a:solidFill>
-              <a:srgbClr val="7F8F73"/>
-            </a:solidFill>
-          </a:ln>
-          <a:effectLst/>
-        </p:spPr>
-        <p:style>
-          <a:lnRef idx="1">
-            <a:schemeClr val="accent1"/>
-          </a:lnRef>
-          <a:fillRef idx="3">
-            <a:schemeClr val="accent1"/>
-          </a:fillRef>
-          <a:effectRef idx="2">
-            <a:schemeClr val="accent1"/>
-          </a:effectRef>
-          <a:fontRef idx="minor">
-            <a:schemeClr val="lt1"/>
-          </a:fontRef>
-        </p:style>
-        <p:txBody>
-          <a:bodyPr rtlCol="0" anchor="ctr"/>
-          <a:lstStyle/>
-          <a:p>
-            <a:pPr algn="ctr"/>
-          </a:p>
-        </p:txBody>
-      </p:sp>
-      <p:sp>
-        <p:nvSpPr>
-          <p:cNvPr id="62" name="Rectangle 61"/>
-          <p:cNvSpPr/>
-          <p:nvPr/>
-        </p:nvSpPr>
-        <p:spPr>
-          <a:xfrm>
-            <a:off x="8886825" y="9858375"/>
-            <a:ext cx="514350" cy="57150"/>
-          </a:xfrm>
-          <a:prstGeom prst="rect">
-            <a:avLst/>
-          </a:prstGeom>
-          <a:noFill/>
-          <a:ln w="19050">
-            <a:solidFill>
-              <a:srgbClr val="7F8F73"/>
-            </a:solidFill>
-          </a:ln>
-          <a:effectLst/>
-        </p:spPr>
-        <p:style>
-          <a:lnRef idx="1">
-            <a:schemeClr val="accent1"/>
-          </a:lnRef>
-          <a:fillRef idx="3">
-            <a:schemeClr val="accent1"/>
-          </a:fillRef>
-          <a:effectRef idx="2">
-            <a:schemeClr val="accent1"/>
-          </a:effectRef>
-          <a:fontRef idx="minor">
-            <a:schemeClr val="lt1"/>
-          </a:fontRef>
-        </p:style>
-        <p:txBody>
-          <a:bodyPr rtlCol="0" anchor="ctr"/>
-          <a:lstStyle/>
-          <a:p>
-            <a:pPr algn="ctr"/>
-          </a:p>
-        </p:txBody>
-      </p:sp>
-      <p:sp>
-        <p:nvSpPr>
-          <p:cNvPr id="63" name="Rounded Rectangle 62"/>
-          <p:cNvSpPr/>
-          <p:nvPr/>
-        </p:nvSpPr>
-        <p:spPr>
-          <a:xfrm>
-            <a:off x="9746742" y="9001125"/>
-            <a:ext cx="128016" cy="2667000"/>
-          </a:xfrm>
-          <a:prstGeom prst="roundRect">
-            <a:avLst>
-              <a:gd name="adj" fmla="val 50000"/>
-            </a:avLst>
-          </a:prstGeom>
-          <a:noFill/>
-          <a:ln w="19050">
-            <a:solidFill>
-              <a:srgbClr val="7F8F73"/>
-            </a:solidFill>
-          </a:ln>
-          <a:effectLst/>
-        </p:spPr>
-        <p:style>
-          <a:lnRef idx="1">
-            <a:schemeClr val="accent1"/>
-          </a:lnRef>
-          <a:fillRef idx="3">
-            <a:schemeClr val="accent1"/>
-          </a:fillRef>
-          <a:effectRef idx="2">
-            <a:schemeClr val="accent1"/>
-          </a:effectRef>
-          <a:fontRef idx="minor">
-            <a:schemeClr val="lt1"/>
-          </a:fontRef>
-        </p:style>
-        <p:txBody>
-          <a:bodyPr rtlCol="0" anchor="ctr"/>
-          <a:lstStyle/>
-          <a:p>
-            <a:pPr algn="ctr"/>
-          </a:p>
-        </p:txBody>
-      </p:sp>
-      <p:sp>
-        <p:nvSpPr>
-          <p:cNvPr id="64" name="Round Same Side Corner Rectangle 63"/>
-          <p:cNvSpPr/>
-          <p:nvPr/>
-        </p:nvSpPr>
-        <p:spPr>
-          <a:xfrm>
-            <a:off x="9410700" y="8759094"/>
-            <a:ext cx="800100" cy="440055"/>
-          </a:xfrm>
-          <a:prstGeom prst="round2SameRect">
-            <a:avLst>
-              <a:gd name="adj1" fmla="val 50000"/>
-              <a:gd name="adj2" fmla="val 0"/>
-            </a:avLst>
-          </a:prstGeom>
-          <a:noFill/>
-          <a:ln w="19050">
-            <a:solidFill>
-              <a:srgbClr val="7F8F73"/>
-            </a:solidFill>
-          </a:ln>
-          <a:effectLst/>
-        </p:spPr>
-        <p:style>
-          <a:lnRef idx="1">
-            <a:schemeClr val="accent1"/>
-          </a:lnRef>
-          <a:fillRef idx="3">
-            <a:schemeClr val="accent1"/>
-          </a:fillRef>
-          <a:effectRef idx="2">
-            <a:schemeClr val="accent1"/>
-          </a:effectRef>
-          <a:fontRef idx="minor">
-            <a:schemeClr val="lt1"/>
-          </a:fontRef>
-        </p:style>
-        <p:txBody>
-          <a:bodyPr rtlCol="0" anchor="ctr"/>
-          <a:lstStyle/>
-          <a:p>
-            <a:pPr algn="ctr"/>
-          </a:p>
-        </p:txBody>
-      </p:sp>
-      <p:sp>
-        <p:nvSpPr>
-          <p:cNvPr id="65" name="Rectangle 64"/>
-          <p:cNvSpPr/>
-          <p:nvPr/>
-        </p:nvSpPr>
-        <p:spPr>
-          <a:xfrm>
-            <a:off x="9467850" y="9001125"/>
-            <a:ext cx="685800" cy="57150"/>
-          </a:xfrm>
-          <a:prstGeom prst="rect">
-            <a:avLst/>
-          </a:prstGeom>
-          <a:noFill/>
-          <a:ln w="19050">
-            <a:solidFill>
-              <a:srgbClr val="7F8F73"/>
-            </a:solidFill>
-          </a:ln>
-          <a:effectLst/>
-        </p:spPr>
-        <p:style>
-          <a:lnRef idx="1">
-            <a:schemeClr val="accent1"/>
-          </a:lnRef>
-          <a:fillRef idx="3">
-            <a:schemeClr val="accent1"/>
-          </a:fillRef>
-          <a:effectRef idx="2">
-            <a:schemeClr val="accent1"/>
-          </a:effectRef>
-          <a:fontRef idx="minor">
-            <a:schemeClr val="lt1"/>
-          </a:fontRef>
-        </p:style>
-        <p:txBody>
-          <a:bodyPr rtlCol="0" anchor="ctr"/>
-          <a:lstStyle/>
-          <a:p>
-            <a:pPr algn="ctr"/>
-          </a:p>
-        </p:txBody>
-      </p:sp>
-      <p:sp>
-        <p:nvSpPr>
-          <p:cNvPr id="66" name="Rounded Rectangle 65"/>
-          <p:cNvSpPr/>
-          <p:nvPr/>
-        </p:nvSpPr>
-        <p:spPr>
-          <a:xfrm>
-            <a:off x="5667375" y="10239375"/>
-            <a:ext cx="95250" cy="1428750"/>
-          </a:xfrm>
-          <a:prstGeom prst="roundRect">
-            <a:avLst>
-              <a:gd name="adj" fmla="val 50000"/>
-            </a:avLst>
-          </a:prstGeom>
-          <a:noFill/>
-          <a:ln w="19050">
-            <a:solidFill>
-              <a:srgbClr val="7F8F73"/>
-            </a:solidFill>
-          </a:ln>
-          <a:effectLst/>
-        </p:spPr>
-        <p:style>
-          <a:lnRef idx="1">
-            <a:schemeClr val="accent1"/>
-          </a:lnRef>
-          <a:fillRef idx="3">
-            <a:schemeClr val="accent1"/>
-          </a:fillRef>
-          <a:effectRef idx="2">
-            <a:schemeClr val="accent1"/>
-          </a:effectRef>
-          <a:fontRef idx="minor">
-            <a:schemeClr val="lt1"/>
-          </a:fontRef>
-        </p:style>
-        <p:txBody>
-          <a:bodyPr rtlCol="0" anchor="ctr"/>
-          <a:lstStyle/>
-          <a:p>
-            <a:pPr algn="ctr"/>
-          </a:p>
-        </p:txBody>
-      </p:sp>
-      <p:sp>
-        <p:nvSpPr>
-          <p:cNvPr id="67" name="Round Same Side Corner Rectangle 66"/>
-          <p:cNvSpPr/>
-          <p:nvPr/>
-        </p:nvSpPr>
-        <p:spPr>
-          <a:xfrm>
-            <a:off x="5448300" y="10078021"/>
-            <a:ext cx="533400" cy="293370"/>
-          </a:xfrm>
-          <a:prstGeom prst="round2SameRect">
-            <a:avLst>
-              <a:gd name="adj1" fmla="val 50000"/>
-              <a:gd name="adj2" fmla="val 0"/>
-            </a:avLst>
-          </a:prstGeom>
-          <a:noFill/>
-          <a:ln w="19050">
-            <a:solidFill>
-              <a:srgbClr val="7F8F73"/>
-            </a:solidFill>
-          </a:ln>
-          <a:effectLst/>
-        </p:spPr>
-        <p:style>
-          <a:lnRef idx="1">
-            <a:schemeClr val="accent1"/>
-          </a:lnRef>
-          <a:fillRef idx="3">
-            <a:schemeClr val="accent1"/>
-          </a:fillRef>
-          <a:effectRef idx="2">
-            <a:schemeClr val="accent1"/>
-          </a:effectRef>
-          <a:fontRef idx="minor">
-            <a:schemeClr val="lt1"/>
-          </a:fontRef>
-        </p:style>
-        <p:txBody>
-          <a:bodyPr rtlCol="0" anchor="ctr"/>
-          <a:lstStyle/>
-          <a:p>
-            <a:pPr algn="ctr"/>
-          </a:p>
-        </p:txBody>
-      </p:sp>
-      <p:sp>
-        <p:nvSpPr>
-          <p:cNvPr id="68" name="Rectangle 67"/>
-          <p:cNvSpPr/>
-          <p:nvPr/>
-        </p:nvSpPr>
-        <p:spPr>
-          <a:xfrm>
-            <a:off x="5505450" y="10239375"/>
-            <a:ext cx="419100" cy="57150"/>
-          </a:xfrm>
-          <a:prstGeom prst="rect">
-            <a:avLst/>
-          </a:prstGeom>
-          <a:noFill/>
-          <a:ln w="19050">
-            <a:solidFill>
-              <a:srgbClr val="7F8F73"/>
-            </a:solidFill>
-          </a:ln>
-          <a:effectLst/>
-        </p:spPr>
-        <p:style>
-          <a:lnRef idx="1">
-            <a:schemeClr val="accent1"/>
-          </a:lnRef>
-          <a:fillRef idx="3">
-            <a:schemeClr val="accent1"/>
-          </a:fillRef>
-          <a:effectRef idx="2">
-            <a:schemeClr val="accent1"/>
-          </a:effectRef>
-          <a:fontRef idx="minor">
-            <a:schemeClr val="lt1"/>
-          </a:fontRef>
-        </p:style>
-        <p:txBody>
-          <a:bodyPr rtlCol="0" anchor="ctr"/>
-          <a:lstStyle/>
-          <a:p>
-            <a:pPr algn="ctr"/>
-          </a:p>
-        </p:txBody>
-      </p:sp>
-      <p:sp>
-        <p:nvSpPr>
-          <p:cNvPr id="69" name="Rounded Rectangle 68"/>
-          <p:cNvSpPr/>
-          <p:nvPr/>
-        </p:nvSpPr>
-        <p:spPr>
-          <a:xfrm>
-            <a:off x="7191375" y="10144125"/>
-            <a:ext cx="95250" cy="1524000"/>
-          </a:xfrm>
-          <a:prstGeom prst="roundRect">
-            <a:avLst>
-              <a:gd name="adj" fmla="val 50000"/>
-            </a:avLst>
-          </a:prstGeom>
-          <a:noFill/>
-          <a:ln w="19050">
-            <a:solidFill>
-              <a:srgbClr val="7F8F73"/>
-            </a:solidFill>
-          </a:ln>
-          <a:effectLst/>
-        </p:spPr>
-        <p:style>
-          <a:lnRef idx="1">
-            <a:schemeClr val="accent1"/>
-          </a:lnRef>
-          <a:fillRef idx="3">
-            <a:schemeClr val="accent1"/>
-          </a:fillRef>
-          <a:effectRef idx="2">
-            <a:schemeClr val="accent1"/>
-          </a:effectRef>
-          <a:fontRef idx="minor">
-            <a:schemeClr val="lt1"/>
-          </a:fontRef>
-        </p:style>
-        <p:txBody>
-          <a:bodyPr rtlCol="0" anchor="ctr"/>
-          <a:lstStyle/>
-          <a:p>
-            <a:pPr algn="ctr"/>
-          </a:p>
-        </p:txBody>
-      </p:sp>
-      <p:sp>
-        <p:nvSpPr>
-          <p:cNvPr id="70" name="Round Same Side Corner Rectangle 69"/>
-          <p:cNvSpPr/>
-          <p:nvPr/>
-        </p:nvSpPr>
-        <p:spPr>
-          <a:xfrm>
-            <a:off x="6953250" y="9971246"/>
-            <a:ext cx="571500" cy="314325"/>
-          </a:xfrm>
-          <a:prstGeom prst="round2SameRect">
-            <a:avLst>
-              <a:gd name="adj1" fmla="val 50000"/>
-              <a:gd name="adj2" fmla="val 0"/>
-            </a:avLst>
-          </a:prstGeom>
-          <a:noFill/>
-          <a:ln w="19050">
-            <a:solidFill>
-              <a:srgbClr val="7F8F73"/>
-            </a:solidFill>
-          </a:ln>
-          <a:effectLst/>
-        </p:spPr>
-        <p:style>
-          <a:lnRef idx="1">
-            <a:schemeClr val="accent1"/>
-          </a:lnRef>
-          <a:fillRef idx="3">
-            <a:schemeClr val="accent1"/>
-          </a:fillRef>
-          <a:effectRef idx="2">
-            <a:schemeClr val="accent1"/>
-          </a:effectRef>
-          <a:fontRef idx="minor">
-            <a:schemeClr val="lt1"/>
-          </a:fontRef>
-        </p:style>
-        <p:txBody>
-          <a:bodyPr rtlCol="0" anchor="ctr"/>
-          <a:lstStyle/>
-          <a:p>
-            <a:pPr algn="ctr"/>
-          </a:p>
-        </p:txBody>
-      </p:sp>
-      <p:sp>
-        <p:nvSpPr>
-          <p:cNvPr id="71" name="Rectangle 70"/>
-          <p:cNvSpPr/>
-          <p:nvPr/>
-        </p:nvSpPr>
-        <p:spPr>
-          <a:xfrm>
-            <a:off x="7010400" y="10144125"/>
-            <a:ext cx="457200" cy="57150"/>
-          </a:xfrm>
-          <a:prstGeom prst="rect">
-            <a:avLst/>
-          </a:prstGeom>
-          <a:noFill/>
-          <a:ln w="19050">
-            <a:solidFill>
-              <a:srgbClr val="7F8F73"/>
-            </a:solidFill>
-          </a:ln>
-          <a:effectLst/>
-        </p:spPr>
-        <p:style>
-          <a:lnRef idx="1">
-            <a:schemeClr val="accent1"/>
-          </a:lnRef>
-          <a:fillRef idx="3">
-            <a:schemeClr val="accent1"/>
-          </a:fillRef>
-          <a:effectRef idx="2">
-            <a:schemeClr val="accent1"/>
-          </a:effectRef>
-          <a:fontRef idx="minor">
-            <a:schemeClr val="lt1"/>
-          </a:fontRef>
-        </p:style>
-        <p:txBody>
-          <a:bodyPr rtlCol="0" anchor="ctr"/>
-          <a:lstStyle/>
-          <a:p>
-            <a:pPr algn="ctr"/>
-          </a:p>
-        </p:txBody>
-      </p:sp>
-      <p:sp>
-        <p:nvSpPr>
-          <p:cNvPr id="72" name="Rounded Rectangle 71"/>
-          <p:cNvSpPr/>
-          <p:nvPr/>
-        </p:nvSpPr>
-        <p:spPr>
-          <a:xfrm>
-            <a:off x="8810625" y="10429875"/>
-            <a:ext cx="95250" cy="1238250"/>
-          </a:xfrm>
-          <a:prstGeom prst="roundRect">
-            <a:avLst>
-              <a:gd name="adj" fmla="val 50000"/>
-            </a:avLst>
-          </a:prstGeom>
-          <a:noFill/>
-          <a:ln w="19050">
-            <a:solidFill>
-              <a:srgbClr val="7F8F73"/>
-            </a:solidFill>
-          </a:ln>
-          <a:effectLst/>
-        </p:spPr>
-        <p:style>
-          <a:lnRef idx="1">
-            <a:schemeClr val="accent1"/>
-          </a:lnRef>
-          <a:fillRef idx="3">
-            <a:schemeClr val="accent1"/>
-          </a:fillRef>
-          <a:effectRef idx="2">
-            <a:schemeClr val="accent1"/>
-          </a:effectRef>
-          <a:fontRef idx="minor">
-            <a:schemeClr val="lt1"/>
-          </a:fontRef>
-        </p:style>
-        <p:txBody>
-          <a:bodyPr rtlCol="0" anchor="ctr"/>
-          <a:lstStyle/>
-          <a:p>
-            <a:pPr algn="ctr"/>
-          </a:p>
-        </p:txBody>
-      </p:sp>
-      <p:sp>
-        <p:nvSpPr>
-          <p:cNvPr id="73" name="Round Same Side Corner Rectangle 72"/>
-          <p:cNvSpPr/>
-          <p:nvPr/>
-        </p:nvSpPr>
-        <p:spPr>
-          <a:xfrm>
-            <a:off x="8610600" y="10280046"/>
-            <a:ext cx="495300" cy="272415"/>
-          </a:xfrm>
-          <a:prstGeom prst="round2SameRect">
-            <a:avLst>
-              <a:gd name="adj1" fmla="val 50000"/>
-              <a:gd name="adj2" fmla="val 0"/>
-            </a:avLst>
-          </a:prstGeom>
-          <a:noFill/>
-          <a:ln w="19050">
-            <a:solidFill>
-              <a:srgbClr val="7F8F73"/>
-            </a:solidFill>
-          </a:ln>
-          <a:effectLst/>
-        </p:spPr>
-        <p:style>
-          <a:lnRef idx="1">
-            <a:schemeClr val="accent1"/>
-          </a:lnRef>
-          <a:fillRef idx="3">
-            <a:schemeClr val="accent1"/>
-          </a:fillRef>
-          <a:effectRef idx="2">
-            <a:schemeClr val="accent1"/>
-          </a:effectRef>
-          <a:fontRef idx="minor">
-            <a:schemeClr val="lt1"/>
-          </a:fontRef>
-        </p:style>
-        <p:txBody>
-          <a:bodyPr rtlCol="0" anchor="ctr"/>
-          <a:lstStyle/>
-          <a:p>
-            <a:pPr algn="ctr"/>
-          </a:p>
-        </p:txBody>
-      </p:sp>
-      <p:sp>
-        <p:nvSpPr>
-          <p:cNvPr id="74" name="Rectangle 73"/>
-          <p:cNvSpPr/>
-          <p:nvPr/>
-        </p:nvSpPr>
-        <p:spPr>
-          <a:xfrm>
-            <a:off x="8667750" y="10429875"/>
-            <a:ext cx="381000" cy="57150"/>
-          </a:xfrm>
-          <a:prstGeom prst="rect">
-            <a:avLst/>
-          </a:prstGeom>
-          <a:noFill/>
-          <a:ln w="19050">
-            <a:solidFill>
-              <a:srgbClr val="7F8F73"/>
-            </a:solidFill>
-          </a:ln>
-          <a:effectLst/>
-        </p:spPr>
-        <p:style>
-          <a:lnRef idx="1">
-            <a:schemeClr val="accent1"/>
-          </a:lnRef>
-          <a:fillRef idx="3">
-            <a:schemeClr val="accent1"/>
-          </a:fillRef>
-          <a:effectRef idx="2">
-            <a:schemeClr val="accent1"/>
-          </a:effectRef>
-          <a:fontRef idx="minor">
-            <a:schemeClr val="lt1"/>
-          </a:fontRef>
-        </p:style>
-        <p:txBody>
-          <a:bodyPr rtlCol="0" anchor="ctr"/>
-          <a:lstStyle/>
-          <a:p>
-            <a:pPr algn="ctr"/>
-          </a:p>
-        </p:txBody>
-      </p:sp>
       <p:pic>
         <p:nvPicPr>
-          <p:cNvPr id="75" name="Picture 74" descr="2231625383167847145.jpg"/>
+          <p:cNvPr id="2" name="Picture 1" descr="cut-green-scribble.png"/>
           <p:cNvPicPr>
             <a:picLocks noChangeAspect="1"/>
           </p:cNvPicPr>
@@ -6896,6 +3526,126 @@
         </p:nvPicPr>
         <p:blipFill>
           <a:blip r:embed="rId3"/>
+          <a:stretch>
+            <a:fillRect/>
+          </a:stretch>
+        </p:blipFill>
+        <p:spPr>
+          <a:xfrm rot="21120000">
+            <a:off x="-381000" y="-285750"/>
+            <a:ext cx="2095500" cy="2889250"/>
+          </a:xfrm>
+          <a:prstGeom prst="rect">
+            <a:avLst/>
+          </a:prstGeom>
+        </p:spPr>
+      </p:pic>
+      <p:pic>
+        <p:nvPicPr>
+          <p:cNvPr id="3" name="Picture 2" descr="cut-blue-lines.png"/>
+          <p:cNvPicPr>
+            <a:picLocks noChangeAspect="1"/>
+          </p:cNvPicPr>
+          <p:nvPr/>
+        </p:nvPicPr>
+        <p:blipFill>
+          <a:blip r:embed="rId4"/>
+          <a:stretch>
+            <a:fillRect/>
+          </a:stretch>
+        </p:blipFill>
+        <p:spPr>
+          <a:xfrm rot="600000">
+            <a:off x="8382000" y="-190500"/>
+            <a:ext cx="1905000" cy="2312051"/>
+          </a:xfrm>
+          <a:prstGeom prst="rect">
+            <a:avLst/>
+          </a:prstGeom>
+        </p:spPr>
+      </p:pic>
+      <p:pic>
+        <p:nvPicPr>
+          <p:cNvPr id="4" name="Picture 3" descr="cut-sage-dots.png"/>
+          <p:cNvPicPr>
+            <a:picLocks noChangeAspect="1"/>
+          </p:cNvPicPr>
+          <p:nvPr/>
+        </p:nvPicPr>
+        <p:blipFill>
+          <a:blip r:embed="rId5"/>
+          <a:stretch>
+            <a:fillRect/>
+          </a:stretch>
+        </p:blipFill>
+        <p:spPr>
+          <a:xfrm rot="21240000">
+            <a:off x="5810250" y="7334250"/>
+            <a:ext cx="2190750" cy="2190750"/>
+          </a:xfrm>
+          <a:prstGeom prst="rect">
+            <a:avLst/>
+          </a:prstGeom>
+        </p:spPr>
+      </p:pic>
+      <p:pic>
+        <p:nvPicPr>
+          <p:cNvPr id="5" name="Picture 4" descr="stones-stack.png"/>
+          <p:cNvPicPr>
+            <a:picLocks noChangeAspect="1"/>
+          </p:cNvPicPr>
+          <p:nvPr/>
+        </p:nvPicPr>
+        <p:blipFill>
+          <a:blip r:embed="rId6"/>
+          <a:stretch>
+            <a:fillRect/>
+          </a:stretch>
+        </p:blipFill>
+        <p:spPr>
+          <a:xfrm>
+            <a:off x="8382000" y="6858000"/>
+            <a:ext cx="1549196" cy="4476750"/>
+          </a:xfrm>
+          <a:prstGeom prst="rect">
+            <a:avLst/>
+          </a:prstGeom>
+        </p:spPr>
+      </p:pic>
+      <p:pic>
+        <p:nvPicPr>
+          <p:cNvPr id="6" name="Picture 5" descr="fern-green.png"/>
+          <p:cNvPicPr>
+            <a:picLocks noChangeAspect="1"/>
+          </p:cNvPicPr>
+          <p:nvPr/>
+        </p:nvPicPr>
+        <p:blipFill>
+          <a:blip r:embed="rId7"/>
+          <a:stretch>
+            <a:fillRect/>
+          </a:stretch>
+        </p:blipFill>
+        <p:spPr>
+          <a:xfrm rot="21360000">
+            <a:off x="5334000" y="9620250"/>
+            <a:ext cx="4476750" cy="2307921"/>
+          </a:xfrm>
+          <a:prstGeom prst="rect">
+            <a:avLst/>
+          </a:prstGeom>
+        </p:spPr>
+      </p:pic>
+      <p:pic>
+        <p:nvPicPr>
+          <p:cNvPr id="7" name="Picture 6" descr="2636369435674524458.jpg"/>
+          <p:cNvPicPr>
+            <a:picLocks noChangeAspect="1"/>
+          </p:cNvPicPr>
+          <p:nvPr/>
+        </p:nvPicPr>
+        <p:blipFill>
+          <a:blip r:embed="rId8"/>
           <a:stretch>
             <a:fillRect/>
           </a:stretch>
@@ -6912,7 +3662,7 @@
       </p:pic>
       <p:sp>
         <p:nvSpPr>
-          <p:cNvPr id="76" name="TextBox 75"/>
+          <p:cNvPr id="8" name="TextBox 7"/>
           <p:cNvSpPr txBox="1"/>
           <p:nvPr/>
         </p:nvSpPr>
@@ -6953,7 +3703,7 @@
       </p:sp>
       <p:sp>
         <p:nvSpPr>
-          <p:cNvPr id="77" name="TextBox 76"/>
+          <p:cNvPr id="9" name="TextBox 8"/>
           <p:cNvSpPr txBox="1"/>
           <p:nvPr/>
         </p:nvSpPr>
@@ -6992,7 +3742,7 @@
       </p:sp>
       <p:sp>
         <p:nvSpPr>
-          <p:cNvPr id="78" name="Rectangle 77"/>
+          <p:cNvPr id="10" name="Rectangle 9"/>
           <p:cNvSpPr/>
           <p:nvPr/>
         </p:nvSpPr>
@@ -7036,7 +3786,7 @@
       </p:sp>
       <p:sp>
         <p:nvSpPr>
-          <p:cNvPr id="79" name="TextBox 78"/>
+          <p:cNvPr id="11" name="TextBox 10"/>
           <p:cNvSpPr txBox="1"/>
           <p:nvPr/>
         </p:nvSpPr>
@@ -7075,7 +3825,7 @@
       </p:sp>
       <p:sp>
         <p:nvSpPr>
-          <p:cNvPr id="80" name="TextBox 79"/>
+          <p:cNvPr id="12" name="TextBox 11"/>
           <p:cNvSpPr txBox="1"/>
           <p:nvPr/>
         </p:nvSpPr>
@@ -7114,7 +3864,7 @@
       </p:sp>
       <p:sp>
         <p:nvSpPr>
-          <p:cNvPr id="81" name="Rectangle 80"/>
+          <p:cNvPr id="13" name="Rectangle 12"/>
           <p:cNvSpPr/>
           <p:nvPr/>
         </p:nvSpPr>
@@ -7158,14 +3908,14 @@
       </p:sp>
       <p:pic>
         <p:nvPicPr>
-          <p:cNvPr id="82" name="Picture 81" descr="foundation-logo-white.png"/>
+          <p:cNvPr id="14" name="Picture 13" descr="foundation-logo-white.png"/>
           <p:cNvPicPr>
             <a:picLocks noChangeAspect="1"/>
           </p:cNvPicPr>
           <p:nvPr/>
         </p:nvPicPr>
         <p:blipFill>
-          <a:blip r:embed="rId4"/>
+          <a:blip r:embed="rId9"/>
           <a:stretch>
             <a:fillRect/>
           </a:stretch>
@@ -7182,7 +3932,7 @@
       </p:pic>
       <p:sp>
         <p:nvSpPr>
-          <p:cNvPr id="83" name="TextBox 82"/>
+          <p:cNvPr id="15" name="TextBox 14"/>
           <p:cNvSpPr txBox="1"/>
           <p:nvPr/>
         </p:nvSpPr>
@@ -7221,7 +3971,7 @@
       </p:sp>
       <p:sp>
         <p:nvSpPr>
-          <p:cNvPr id="84" name="TextBox 83"/>
+          <p:cNvPr id="16" name="TextBox 15"/>
           <p:cNvSpPr txBox="1"/>
           <p:nvPr/>
         </p:nvSpPr>

</xml_diff>